<commit_message>
Created basic project scaffold
</commit_message>
<xml_diff>
--- a/Task 6/BrainPath_Backend Engineering Report Group9.pptx
+++ b/Task 6/BrainPath_Backend Engineering Report Group9.pptx
@@ -5,18 +5,17 @@
     <p:sldMasterId id="2147483659" r:id="rId1"/>
   </p:sldMasterIdLst>
   <p:notesMasterIdLst>
-    <p:notesMasterId r:id="rId11"/>
+    <p:notesMasterId r:id="rId10"/>
   </p:notesMasterIdLst>
   <p:sldIdLst>
     <p:sldId id="256" r:id="rId2"/>
     <p:sldId id="257" r:id="rId3"/>
-    <p:sldId id="258" r:id="rId4"/>
+    <p:sldId id="266" r:id="rId4"/>
     <p:sldId id="259" r:id="rId5"/>
     <p:sldId id="260" r:id="rId6"/>
     <p:sldId id="261" r:id="rId7"/>
     <p:sldId id="262" r:id="rId8"/>
     <p:sldId id="263" r:id="rId9"/>
-    <p:sldId id="264" r:id="rId10"/>
   </p:sldIdLst>
   <p:sldSz cx="12192000" cy="6858000"/>
   <p:notesSz cx="6858000" cy="9144000"/>
@@ -922,7 +921,13 @@
   <p:cSld>
     <p:spTree>
       <p:nvGrpSpPr>
-        <p:cNvPr id="1" name="Shape 107"/>
+        <p:cNvPr id="1" name="Shape 107">
+          <a:extLst>
+            <a:ext uri="{FF2B5EF4-FFF2-40B4-BE49-F238E27FC236}">
+              <a16:creationId xmlns:a16="http://schemas.microsoft.com/office/drawing/2014/main" id="{8960483E-C61C-AD91-83A3-FF073DA4D92F}"/>
+            </a:ext>
+          </a:extLst>
+        </p:cNvPr>
         <p:cNvGrpSpPr/>
         <p:nvPr/>
       </p:nvGrpSpPr>
@@ -936,7 +941,13 @@
       </p:grpSpPr>
       <p:sp>
         <p:nvSpPr>
-          <p:cNvPr id="108" name="Google Shape;108;p3:notes"/>
+          <p:cNvPr id="108" name="Google Shape;108;p3:notes">
+            <a:extLst>
+              <a:ext uri="{FF2B5EF4-FFF2-40B4-BE49-F238E27FC236}">
+                <a16:creationId xmlns:a16="http://schemas.microsoft.com/office/drawing/2014/main" id="{A158C471-CF0F-B712-8CD2-D16B234B48D8}"/>
+              </a:ext>
+            </a:extLst>
+          </p:cNvPr>
           <p:cNvSpPr txBox="1">
             <a:spLocks noGrp="1"/>
           </p:cNvSpPr>
@@ -974,7 +985,13 @@
       </p:sp>
       <p:sp>
         <p:nvSpPr>
-          <p:cNvPr id="109" name="Google Shape;109;p3:notes"/>
+          <p:cNvPr id="109" name="Google Shape;109;p3:notes">
+            <a:extLst>
+              <a:ext uri="{FF2B5EF4-FFF2-40B4-BE49-F238E27FC236}">
+                <a16:creationId xmlns:a16="http://schemas.microsoft.com/office/drawing/2014/main" id="{BF89B43C-3632-85DA-A314-20561CBD99E6}"/>
+              </a:ext>
+            </a:extLst>
+          </p:cNvPr>
           <p:cNvSpPr>
             <a:spLocks noGrp="1" noRot="1" noChangeAspect="1"/>
           </p:cNvSpPr>
@@ -1014,6 +1031,11 @@
         </p:spPr>
       </p:sp>
     </p:spTree>
+    <p:extLst>
+      <p:ext uri="{BB962C8B-B14F-4D97-AF65-F5344CB8AC3E}">
+        <p14:creationId xmlns:p14="http://schemas.microsoft.com/office/powerpoint/2010/main" val="3813098816"/>
+      </p:ext>
+    </p:extLst>
   </p:cSld>
   <p:clrMapOvr>
     <a:masterClrMapping/>
@@ -1495,110 +1517,6 @@
       <p:sp>
         <p:nvSpPr>
           <p:cNvPr id="191" name="Google Shape;191;p8:notes"/>
-          <p:cNvSpPr>
-            <a:spLocks noGrp="1" noRot="1" noChangeAspect="1"/>
-          </p:cNvSpPr>
-          <p:nvPr>
-            <p:ph type="sldImg" idx="2"/>
-          </p:nvPr>
-        </p:nvSpPr>
-        <p:spPr>
-          <a:xfrm>
-            <a:off x="381000" y="685800"/>
-            <a:ext cx="6096000" cy="3429000"/>
-          </a:xfrm>
-          <a:custGeom>
-            <a:avLst/>
-            <a:gdLst/>
-            <a:ahLst/>
-            <a:cxnLst/>
-            <a:rect l="l" t="t" r="r" b="b"/>
-            <a:pathLst>
-              <a:path w="120000" h="120000" extrusionOk="0">
-                <a:moveTo>
-                  <a:pt x="0" y="0"/>
-                </a:moveTo>
-                <a:lnTo>
-                  <a:pt x="120000" y="0"/>
-                </a:lnTo>
-                <a:lnTo>
-                  <a:pt x="120000" y="120000"/>
-                </a:lnTo>
-                <a:lnTo>
-                  <a:pt x="0" y="120000"/>
-                </a:lnTo>
-                <a:close/>
-              </a:path>
-            </a:pathLst>
-          </a:custGeom>
-        </p:spPr>
-      </p:sp>
-    </p:spTree>
-  </p:cSld>
-  <p:clrMapOvr>
-    <a:masterClrMapping/>
-  </p:clrMapOvr>
-</p:notes>
-</file>
-
-<file path=ppt/notesSlides/notesSlide9.xml><?xml version="1.0" encoding="utf-8"?>
-<p:notes xmlns:a="http://schemas.openxmlformats.org/drawingml/2006/main" xmlns:r="http://schemas.openxmlformats.org/officeDocument/2006/relationships" xmlns:p="http://schemas.openxmlformats.org/presentationml/2006/main" showMasterSp="0" showMasterPhAnim="0">
-  <p:cSld>
-    <p:spTree>
-      <p:nvGrpSpPr>
-        <p:cNvPr id="1" name="Shape 202"/>
-        <p:cNvGrpSpPr/>
-        <p:nvPr/>
-      </p:nvGrpSpPr>
-      <p:grpSpPr>
-        <a:xfrm>
-          <a:off x="0" y="0"/>
-          <a:ext cx="0" cy="0"/>
-          <a:chOff x="0" y="0"/>
-          <a:chExt cx="0" cy="0"/>
-        </a:xfrm>
-      </p:grpSpPr>
-      <p:sp>
-        <p:nvSpPr>
-          <p:cNvPr id="203" name="Google Shape;203;p9:notes"/>
-          <p:cNvSpPr txBox="1">
-            <a:spLocks noGrp="1"/>
-          </p:cNvSpPr>
-          <p:nvPr>
-            <p:ph type="body" idx="1"/>
-          </p:nvPr>
-        </p:nvSpPr>
-        <p:spPr>
-          <a:xfrm>
-            <a:off x="685800" y="4343400"/>
-            <a:ext cx="5486400" cy="4114800"/>
-          </a:xfrm>
-          <a:prstGeom prst="rect">
-            <a:avLst/>
-          </a:prstGeom>
-        </p:spPr>
-        <p:txBody>
-          <a:bodyPr spcFirstLastPara="1" wrap="square" lIns="91425" tIns="91425" rIns="91425" bIns="91425" anchor="t" anchorCtr="0">
-            <a:noAutofit/>
-          </a:bodyPr>
-          <a:lstStyle/>
-          <a:p>
-            <a:pPr marL="0" lvl="0" indent="0" algn="l" rtl="0">
-              <a:spcBef>
-                <a:spcPts val="0"/>
-              </a:spcBef>
-              <a:spcAft>
-                <a:spcPts val="0"/>
-              </a:spcAft>
-              <a:buNone/>
-            </a:pPr>
-            <a:endParaRPr/>
-          </a:p>
-        </p:txBody>
-      </p:sp>
-      <p:sp>
-        <p:nvSpPr>
-          <p:cNvPr id="204" name="Google Shape;204;p9:notes"/>
           <p:cNvSpPr>
             <a:spLocks noGrp="1" noRot="1" noChangeAspect="1"/>
           </p:cNvSpPr>
@@ -11916,505 +11834,6 @@
           </a:ln>
         </p:spPr>
       </p:pic>
-      <p:pic>
-        <p:nvPicPr>
-          <p:cNvPr id="94" name="Google Shape;94;p14" descr="image.png"/>
-          <p:cNvPicPr preferRelativeResize="0"/>
-          <p:nvPr/>
-        </p:nvPicPr>
-        <p:blipFill rotWithShape="1">
-          <a:blip r:embed="rId4">
-            <a:alphaModFix/>
-          </a:blip>
-          <a:srcRect/>
-          <a:stretch/>
-        </p:blipFill>
-        <p:spPr>
-          <a:xfrm>
-            <a:off x="7372350" y="1900237"/>
-            <a:ext cx="4152900" cy="4000500"/>
-          </a:xfrm>
-          <a:prstGeom prst="rect">
-            <a:avLst/>
-          </a:prstGeom>
-          <a:noFill/>
-          <a:ln>
-            <a:noFill/>
-          </a:ln>
-        </p:spPr>
-      </p:pic>
-      <p:sp>
-        <p:nvSpPr>
-          <p:cNvPr id="95" name="Google Shape;95;p14"/>
-          <p:cNvSpPr txBox="1"/>
-          <p:nvPr/>
-        </p:nvSpPr>
-        <p:spPr>
-          <a:xfrm>
-            <a:off x="666750" y="2714625"/>
-            <a:ext cx="6229350" cy="542925"/>
-          </a:xfrm>
-          <a:prstGeom prst="rect">
-            <a:avLst/>
-          </a:prstGeom>
-          <a:noFill/>
-          <a:ln>
-            <a:noFill/>
-          </a:ln>
-        </p:spPr>
-        <p:txBody>
-          <a:bodyPr spcFirstLastPara="1" wrap="square" lIns="0" tIns="0" rIns="0" bIns="0" anchor="t" anchorCtr="0">
-            <a:spAutoFit/>
-          </a:bodyPr>
-          <a:lstStyle/>
-          <a:p>
-            <a:pPr marL="0" marR="0" lvl="0" indent="0" algn="l" rtl="0">
-              <a:lnSpc>
-                <a:spcPct val="149964"/>
-              </a:lnSpc>
-              <a:spcBef>
-                <a:spcPts val="0"/>
-              </a:spcBef>
-              <a:spcAft>
-                <a:spcPts val="0"/>
-              </a:spcAft>
-              <a:buNone/>
-            </a:pPr>
-            <a:r>
-              <a:rPr lang="en-US" sz="1425" b="0" i="0" u="none" strike="noStrike" cap="none">
-                <a:solidFill>
-                  <a:srgbClr val="334155"/>
-                </a:solidFill>
-                <a:latin typeface="Inter"/>
-                <a:ea typeface="Inter"/>
-                <a:cs typeface="Inter"/>
-                <a:sym typeface="Inter"/>
-              </a:rPr>
-              <a:t>This phase focuses on translating academic requirements into a scalable </a:t>
-            </a:r>
-            <a:r>
-              <a:rPr lang="en-US" sz="1425" b="0" i="0" u="none" strike="noStrike" cap="none">
-                <a:solidFill>
-                  <a:srgbClr val="0F172A"/>
-                </a:solidFill>
-                <a:latin typeface="Inter"/>
-                <a:ea typeface="Inter"/>
-                <a:cs typeface="Inter"/>
-                <a:sym typeface="Inter"/>
-              </a:rPr>
-              <a:t>Full-Stack architecture</a:t>
-            </a:r>
-            <a:r>
-              <a:rPr lang="en-US" sz="1425" b="0" i="0" u="none" strike="noStrike" cap="none">
-                <a:solidFill>
-                  <a:srgbClr val="334155"/>
-                </a:solidFill>
-                <a:latin typeface="Inter"/>
-                <a:ea typeface="Inter"/>
-                <a:cs typeface="Inter"/>
-                <a:sym typeface="Inter"/>
-              </a:rPr>
-              <a:t>.</a:t>
-            </a:r>
-            <a:endParaRPr/>
-          </a:p>
-        </p:txBody>
-      </p:sp>
-      <p:pic>
-        <p:nvPicPr>
-          <p:cNvPr id="96" name="Google Shape;96;p14" descr="image.png"/>
-          <p:cNvPicPr preferRelativeResize="0"/>
-          <p:nvPr/>
-        </p:nvPicPr>
-        <p:blipFill rotWithShape="1">
-          <a:blip r:embed="rId5">
-            <a:alphaModFix/>
-          </a:blip>
-          <a:srcRect/>
-          <a:stretch/>
-        </p:blipFill>
-        <p:spPr>
-          <a:xfrm>
-            <a:off x="7381875" y="1909762"/>
-            <a:ext cx="4133850" cy="3981450"/>
-          </a:xfrm>
-          <a:prstGeom prst="rect">
-            <a:avLst/>
-          </a:prstGeom>
-          <a:noFill/>
-          <a:ln>
-            <a:noFill/>
-          </a:ln>
-        </p:spPr>
-      </p:pic>
-      <p:sp>
-        <p:nvSpPr>
-          <p:cNvPr id="97" name="Google Shape;97;p14"/>
-          <p:cNvSpPr txBox="1"/>
-          <p:nvPr/>
-        </p:nvSpPr>
-        <p:spPr>
-          <a:xfrm>
-            <a:off x="666750" y="3495675"/>
-            <a:ext cx="6229350" cy="271462"/>
-          </a:xfrm>
-          <a:prstGeom prst="rect">
-            <a:avLst/>
-          </a:prstGeom>
-          <a:noFill/>
-          <a:ln>
-            <a:noFill/>
-          </a:ln>
-        </p:spPr>
-        <p:txBody>
-          <a:bodyPr spcFirstLastPara="1" wrap="square" lIns="304800" tIns="0" rIns="0" bIns="0" anchor="t" anchorCtr="0">
-            <a:spAutoFit/>
-          </a:bodyPr>
-          <a:lstStyle/>
-          <a:p>
-            <a:pPr marL="0" marR="0" lvl="0" indent="0" algn="l" rtl="0">
-              <a:lnSpc>
-                <a:spcPct val="149964"/>
-              </a:lnSpc>
-              <a:spcBef>
-                <a:spcPts val="0"/>
-              </a:spcBef>
-              <a:spcAft>
-                <a:spcPts val="0"/>
-              </a:spcAft>
-              <a:buNone/>
-            </a:pPr>
-            <a:r>
-              <a:rPr lang="en-US" sz="1425" b="0" i="0" u="none" strike="noStrike" cap="none">
-                <a:solidFill>
-                  <a:srgbClr val="0F172A"/>
-                </a:solidFill>
-                <a:latin typeface="Inter"/>
-                <a:ea typeface="Inter"/>
-                <a:cs typeface="Inter"/>
-                <a:sym typeface="Inter"/>
-              </a:rPr>
-              <a:t>Data Elements:</a:t>
-            </a:r>
-            <a:r>
-              <a:rPr lang="en-US" sz="1425" b="0" i="0" u="none" strike="noStrike" cap="none">
-                <a:solidFill>
-                  <a:srgbClr val="334155"/>
-                </a:solidFill>
-                <a:latin typeface="Inter"/>
-                <a:ea typeface="Inter"/>
-                <a:cs typeface="Inter"/>
-                <a:sym typeface="Inter"/>
-              </a:rPr>
-              <a:t> Identifying unique entities and user attributes.</a:t>
-            </a:r>
-            <a:endParaRPr/>
-          </a:p>
-        </p:txBody>
-      </p:sp>
-      <p:sp>
-        <p:nvSpPr>
-          <p:cNvPr id="98" name="Google Shape;98;p14"/>
-          <p:cNvSpPr txBox="1"/>
-          <p:nvPr/>
-        </p:nvSpPr>
-        <p:spPr>
-          <a:xfrm>
-            <a:off x="666750" y="3938587"/>
-            <a:ext cx="6229350" cy="271462"/>
-          </a:xfrm>
-          <a:prstGeom prst="rect">
-            <a:avLst/>
-          </a:prstGeom>
-          <a:noFill/>
-          <a:ln>
-            <a:noFill/>
-          </a:ln>
-        </p:spPr>
-        <p:txBody>
-          <a:bodyPr spcFirstLastPara="1" wrap="square" lIns="342900" tIns="0" rIns="0" bIns="0" anchor="t" anchorCtr="0">
-            <a:spAutoFit/>
-          </a:bodyPr>
-          <a:lstStyle/>
-          <a:p>
-            <a:pPr marL="0" marR="0" lvl="0" indent="0" algn="l" rtl="0">
-              <a:lnSpc>
-                <a:spcPct val="149964"/>
-              </a:lnSpc>
-              <a:spcBef>
-                <a:spcPts val="0"/>
-              </a:spcBef>
-              <a:spcAft>
-                <a:spcPts val="0"/>
-              </a:spcAft>
-              <a:buNone/>
-            </a:pPr>
-            <a:r>
-              <a:rPr lang="en-US" sz="1425" b="0" i="0" u="none" strike="noStrike" cap="none">
-                <a:solidFill>
-                  <a:srgbClr val="0F172A"/>
-                </a:solidFill>
-                <a:latin typeface="Inter"/>
-                <a:ea typeface="Inter"/>
-                <a:cs typeface="Inter"/>
-                <a:sym typeface="Inter"/>
-              </a:rPr>
-              <a:t>Relational Modeling:</a:t>
-            </a:r>
-            <a:r>
-              <a:rPr lang="en-US" sz="1425" b="0" i="0" u="none" strike="noStrike" cap="none">
-                <a:solidFill>
-                  <a:srgbClr val="334155"/>
-                </a:solidFill>
-                <a:latin typeface="Inter"/>
-                <a:ea typeface="Inter"/>
-                <a:cs typeface="Inter"/>
-                <a:sym typeface="Inter"/>
-              </a:rPr>
-              <a:t> Blueprinting the system in 3rd Normal Form.</a:t>
-            </a:r>
-            <a:endParaRPr/>
-          </a:p>
-        </p:txBody>
-      </p:sp>
-      <p:sp>
-        <p:nvSpPr>
-          <p:cNvPr id="99" name="Google Shape;99;p14"/>
-          <p:cNvSpPr txBox="1"/>
-          <p:nvPr/>
-        </p:nvSpPr>
-        <p:spPr>
-          <a:xfrm>
-            <a:off x="666750" y="4381500"/>
-            <a:ext cx="6229350" cy="271462"/>
-          </a:xfrm>
-          <a:prstGeom prst="rect">
-            <a:avLst/>
-          </a:prstGeom>
-          <a:noFill/>
-          <a:ln>
-            <a:noFill/>
-          </a:ln>
-        </p:spPr>
-        <p:txBody>
-          <a:bodyPr spcFirstLastPara="1" wrap="square" lIns="371475" tIns="0" rIns="0" bIns="0" anchor="t" anchorCtr="0">
-            <a:spAutoFit/>
-          </a:bodyPr>
-          <a:lstStyle/>
-          <a:p>
-            <a:pPr marL="0" marR="0" lvl="0" indent="0" algn="l" rtl="0">
-              <a:lnSpc>
-                <a:spcPct val="149964"/>
-              </a:lnSpc>
-              <a:spcBef>
-                <a:spcPts val="0"/>
-              </a:spcBef>
-              <a:spcAft>
-                <a:spcPts val="0"/>
-              </a:spcAft>
-              <a:buNone/>
-            </a:pPr>
-            <a:r>
-              <a:rPr lang="en-US" sz="1425" b="0" i="0" u="none" strike="noStrike" cap="none">
-                <a:solidFill>
-                  <a:srgbClr val="0F172A"/>
-                </a:solidFill>
-                <a:latin typeface="Inter"/>
-                <a:ea typeface="Inter"/>
-                <a:cs typeface="Inter"/>
-                <a:sym typeface="Inter"/>
-              </a:rPr>
-              <a:t>API Implementation:</a:t>
-            </a:r>
-            <a:r>
-              <a:rPr lang="en-US" sz="1425" b="0" i="0" u="none" strike="noStrike" cap="none">
-                <a:solidFill>
-                  <a:srgbClr val="334155"/>
-                </a:solidFill>
-                <a:latin typeface="Inter"/>
-                <a:ea typeface="Inter"/>
-                <a:cs typeface="Inter"/>
-                <a:sym typeface="Inter"/>
-              </a:rPr>
-              <a:t> Building the Node.js Express server logic.</a:t>
-            </a:r>
-            <a:endParaRPr/>
-          </a:p>
-        </p:txBody>
-      </p:sp>
-      <p:sp>
-        <p:nvSpPr>
-          <p:cNvPr id="100" name="Google Shape;100;p14"/>
-          <p:cNvSpPr txBox="1"/>
-          <p:nvPr/>
-        </p:nvSpPr>
-        <p:spPr>
-          <a:xfrm>
-            <a:off x="666750" y="4824412"/>
-            <a:ext cx="6229350" cy="271462"/>
-          </a:xfrm>
-          <a:prstGeom prst="rect">
-            <a:avLst/>
-          </a:prstGeom>
-          <a:noFill/>
-          <a:ln>
-            <a:noFill/>
-          </a:ln>
-        </p:spPr>
-        <p:txBody>
-          <a:bodyPr spcFirstLastPara="1" wrap="square" lIns="371475" tIns="0" rIns="0" bIns="0" anchor="t" anchorCtr="0">
-            <a:spAutoFit/>
-          </a:bodyPr>
-          <a:lstStyle/>
-          <a:p>
-            <a:pPr marL="0" marR="0" lvl="0" indent="0" algn="l" rtl="0">
-              <a:lnSpc>
-                <a:spcPct val="149964"/>
-              </a:lnSpc>
-              <a:spcBef>
-                <a:spcPts val="0"/>
-              </a:spcBef>
-              <a:spcAft>
-                <a:spcPts val="0"/>
-              </a:spcAft>
-              <a:buNone/>
-            </a:pPr>
-            <a:r>
-              <a:rPr lang="en-US" sz="1425" b="0" i="0" u="none" strike="noStrike" cap="none">
-                <a:solidFill>
-                  <a:srgbClr val="0F172A"/>
-                </a:solidFill>
-                <a:latin typeface="Inter"/>
-                <a:ea typeface="Inter"/>
-                <a:cs typeface="Inter"/>
-                <a:sym typeface="Inter"/>
-              </a:rPr>
-              <a:t>State Hydration:</a:t>
-            </a:r>
-            <a:r>
-              <a:rPr lang="en-US" sz="1425" b="0" i="0" u="none" strike="noStrike" cap="none">
-                <a:solidFill>
-                  <a:srgbClr val="334155"/>
-                </a:solidFill>
-                <a:latin typeface="Inter"/>
-                <a:ea typeface="Inter"/>
-                <a:cs typeface="Inter"/>
-                <a:sym typeface="Inter"/>
-              </a:rPr>
-              <a:t> Linking database records to the React frontend.</a:t>
-            </a:r>
-            <a:endParaRPr/>
-          </a:p>
-        </p:txBody>
-      </p:sp>
-      <p:pic>
-        <p:nvPicPr>
-          <p:cNvPr id="101" name="Google Shape;101;p14" descr="image.png"/>
-          <p:cNvPicPr preferRelativeResize="0"/>
-          <p:nvPr/>
-        </p:nvPicPr>
-        <p:blipFill rotWithShape="1">
-          <a:blip r:embed="rId6">
-            <a:alphaModFix/>
-          </a:blip>
-          <a:srcRect/>
-          <a:stretch/>
-        </p:blipFill>
-        <p:spPr>
-          <a:xfrm>
-            <a:off x="666750" y="3529012"/>
-            <a:ext cx="161925" cy="190500"/>
-          </a:xfrm>
-          <a:prstGeom prst="rect">
-            <a:avLst/>
-          </a:prstGeom>
-          <a:noFill/>
-          <a:ln>
-            <a:noFill/>
-          </a:ln>
-        </p:spPr>
-      </p:pic>
-      <p:pic>
-        <p:nvPicPr>
-          <p:cNvPr id="102" name="Google Shape;102;p14" descr="image.png"/>
-          <p:cNvPicPr preferRelativeResize="0"/>
-          <p:nvPr/>
-        </p:nvPicPr>
-        <p:blipFill rotWithShape="1">
-          <a:blip r:embed="rId7">
-            <a:alphaModFix/>
-          </a:blip>
-          <a:srcRect/>
-          <a:stretch/>
-        </p:blipFill>
-        <p:spPr>
-          <a:xfrm>
-            <a:off x="666750" y="3971925"/>
-            <a:ext cx="200025" cy="190500"/>
-          </a:xfrm>
-          <a:prstGeom prst="rect">
-            <a:avLst/>
-          </a:prstGeom>
-          <a:noFill/>
-          <a:ln>
-            <a:noFill/>
-          </a:ln>
-        </p:spPr>
-      </p:pic>
-      <p:pic>
-        <p:nvPicPr>
-          <p:cNvPr id="103" name="Google Shape;103;p14" descr="image.png"/>
-          <p:cNvPicPr preferRelativeResize="0"/>
-          <p:nvPr/>
-        </p:nvPicPr>
-        <p:blipFill rotWithShape="1">
-          <a:blip r:embed="rId8">
-            <a:alphaModFix/>
-          </a:blip>
-          <a:srcRect/>
-          <a:stretch/>
-        </p:blipFill>
-        <p:spPr>
-          <a:xfrm>
-            <a:off x="666750" y="4414837"/>
-            <a:ext cx="228600" cy="190500"/>
-          </a:xfrm>
-          <a:prstGeom prst="rect">
-            <a:avLst/>
-          </a:prstGeom>
-          <a:noFill/>
-          <a:ln>
-            <a:noFill/>
-          </a:ln>
-        </p:spPr>
-      </p:pic>
-      <p:pic>
-        <p:nvPicPr>
-          <p:cNvPr id="104" name="Google Shape;104;p14" descr="image.png"/>
-          <p:cNvPicPr preferRelativeResize="0"/>
-          <p:nvPr/>
-        </p:nvPicPr>
-        <p:blipFill rotWithShape="1">
-          <a:blip r:embed="rId9">
-            <a:alphaModFix/>
-          </a:blip>
-          <a:srcRect/>
-          <a:stretch/>
-        </p:blipFill>
-        <p:spPr>
-          <a:xfrm>
-            <a:off x="666750" y="4857750"/>
-            <a:ext cx="228600" cy="190500"/>
-          </a:xfrm>
-          <a:prstGeom prst="rect">
-            <a:avLst/>
-          </a:prstGeom>
-          <a:noFill/>
-          <a:ln>
-            <a:noFill/>
-          </a:ln>
-        </p:spPr>
-      </p:pic>
       <p:sp>
         <p:nvSpPr>
           <p:cNvPr id="105" name="Google Shape;105;p14"/>
@@ -12513,6 +11932,1616 @@
           </a:p>
         </p:txBody>
       </p:sp>
+      <p:sp>
+        <p:nvSpPr>
+          <p:cNvPr id="7" name="Shape 5">
+            <a:extLst>
+              <a:ext uri="{FF2B5EF4-FFF2-40B4-BE49-F238E27FC236}">
+                <a16:creationId xmlns:a16="http://schemas.microsoft.com/office/drawing/2014/main" id="{3C7AD550-B854-C912-3497-F283A16ADCB1}"/>
+              </a:ext>
+            </a:extLst>
+          </p:cNvPr>
+          <p:cNvSpPr/>
+          <p:nvPr/>
+        </p:nvSpPr>
+        <p:spPr>
+          <a:xfrm>
+            <a:off x="1389880" y="2013585"/>
+            <a:ext cx="1600200" cy="3310128"/>
+          </a:xfrm>
+          <a:prstGeom prst="roundRect">
+            <a:avLst>
+              <a:gd name="adj" fmla="val 6857"/>
+            </a:avLst>
+          </a:prstGeom>
+          <a:solidFill>
+            <a:srgbClr val="FFFFFF"/>
+          </a:solidFill>
+          <a:ln w="5080">
+            <a:solidFill>
+              <a:srgbClr val="E2E8F0"/>
+            </a:solidFill>
+            <a:prstDash val="solid"/>
+          </a:ln>
+          <a:effectLst>
+            <a:outerShdw blurRad="101600" dist="38100" dir="2700000" algn="bl" rotWithShape="0">
+              <a:srgbClr val="000000">
+                <a:alpha val="10000"/>
+              </a:srgbClr>
+            </a:outerShdw>
+          </a:effectLst>
+        </p:spPr>
+      </p:sp>
+      <p:sp>
+        <p:nvSpPr>
+          <p:cNvPr id="8" name="Shape 6">
+            <a:extLst>
+              <a:ext uri="{FF2B5EF4-FFF2-40B4-BE49-F238E27FC236}">
+                <a16:creationId xmlns:a16="http://schemas.microsoft.com/office/drawing/2014/main" id="{394A607D-5004-F91E-D236-EC3CC2964AA6}"/>
+              </a:ext>
+            </a:extLst>
+          </p:cNvPr>
+          <p:cNvSpPr/>
+          <p:nvPr/>
+        </p:nvSpPr>
+        <p:spPr>
+          <a:xfrm>
+            <a:off x="1389880" y="2013585"/>
+            <a:ext cx="1600200" cy="347472"/>
+          </a:xfrm>
+          <a:prstGeom prst="roundRect">
+            <a:avLst>
+              <a:gd name="adj" fmla="val 31579"/>
+            </a:avLst>
+          </a:prstGeom>
+          <a:solidFill>
+            <a:srgbClr val="3B82F6"/>
+          </a:solidFill>
+          <a:ln w="12700">
+            <a:solidFill>
+              <a:srgbClr val="3B82F6"/>
+            </a:solidFill>
+            <a:prstDash val="solid"/>
+          </a:ln>
+        </p:spPr>
+      </p:sp>
+      <p:sp>
+        <p:nvSpPr>
+          <p:cNvPr id="9" name="Text 7">
+            <a:extLst>
+              <a:ext uri="{FF2B5EF4-FFF2-40B4-BE49-F238E27FC236}">
+                <a16:creationId xmlns:a16="http://schemas.microsoft.com/office/drawing/2014/main" id="{BD65EBBB-8AB8-8C84-426C-6CB3BED74258}"/>
+              </a:ext>
+            </a:extLst>
+          </p:cNvPr>
+          <p:cNvSpPr/>
+          <p:nvPr/>
+        </p:nvSpPr>
+        <p:spPr>
+          <a:xfrm>
+            <a:off x="1389880" y="2013585"/>
+            <a:ext cx="1600200" cy="347472"/>
+          </a:xfrm>
+          <a:prstGeom prst="rect">
+            <a:avLst/>
+          </a:prstGeom>
+          <a:noFill/>
+          <a:ln/>
+        </p:spPr>
+        <p:txBody>
+          <a:bodyPr wrap="square" lIns="0" tIns="0" rIns="0" bIns="0" rtlCol="0" anchor="ctr"/>
+          <a:lstStyle/>
+          <a:p>
+            <a:pPr marL="0" indent="0" algn="ctr">
+              <a:buNone/>
+            </a:pPr>
+            <a:r>
+              <a:rPr lang="en-US" sz="1400" b="1" dirty="0">
+                <a:solidFill>
+                  <a:srgbClr val="FFFFFF"/>
+                </a:solidFill>
+                <a:latin typeface="Calibri" pitchFamily="34" charset="0"/>
+                <a:ea typeface="Calibri" pitchFamily="34" charset="-122"/>
+                <a:cs typeface="Calibri" pitchFamily="34" charset="-120"/>
+              </a:rPr>
+              <a:t>01</a:t>
+            </a:r>
+            <a:endParaRPr lang="en-US" sz="1400" dirty="0"/>
+          </a:p>
+        </p:txBody>
+      </p:sp>
+      <p:sp>
+        <p:nvSpPr>
+          <p:cNvPr id="10" name="Shape 8">
+            <a:extLst>
+              <a:ext uri="{FF2B5EF4-FFF2-40B4-BE49-F238E27FC236}">
+                <a16:creationId xmlns:a16="http://schemas.microsoft.com/office/drawing/2014/main" id="{327450C3-2369-AA56-5EBE-7953C1FB2CC4}"/>
+              </a:ext>
+            </a:extLst>
+          </p:cNvPr>
+          <p:cNvSpPr/>
+          <p:nvPr/>
+        </p:nvSpPr>
+        <p:spPr>
+          <a:xfrm>
+            <a:off x="1965952" y="2525649"/>
+            <a:ext cx="457200" cy="457200"/>
+          </a:xfrm>
+          <a:prstGeom prst="ellipse">
+            <a:avLst/>
+          </a:prstGeom>
+          <a:solidFill>
+            <a:srgbClr val="3B82F6">
+              <a:alpha val="15000"/>
+            </a:srgbClr>
+          </a:solidFill>
+          <a:ln w="6350">
+            <a:solidFill>
+              <a:srgbClr val="3B82F6"/>
+            </a:solidFill>
+            <a:prstDash val="solid"/>
+          </a:ln>
+        </p:spPr>
+      </p:sp>
+      <p:sp>
+        <p:nvSpPr>
+          <p:cNvPr id="11" name="Text 9">
+            <a:extLst>
+              <a:ext uri="{FF2B5EF4-FFF2-40B4-BE49-F238E27FC236}">
+                <a16:creationId xmlns:a16="http://schemas.microsoft.com/office/drawing/2014/main" id="{E6F3E487-3FD3-DD8C-49E9-1B6948A02568}"/>
+              </a:ext>
+            </a:extLst>
+          </p:cNvPr>
+          <p:cNvSpPr/>
+          <p:nvPr/>
+        </p:nvSpPr>
+        <p:spPr>
+          <a:xfrm>
+            <a:off x="1965952" y="2525649"/>
+            <a:ext cx="457200" cy="457200"/>
+          </a:xfrm>
+          <a:prstGeom prst="rect">
+            <a:avLst/>
+          </a:prstGeom>
+          <a:noFill/>
+          <a:ln/>
+        </p:spPr>
+        <p:txBody>
+          <a:bodyPr wrap="square" lIns="0" tIns="0" rIns="0" bIns="0" rtlCol="0" anchor="ctr"/>
+          <a:lstStyle/>
+          <a:p>
+            <a:pPr marL="0" indent="0" algn="ctr">
+              <a:buNone/>
+            </a:pPr>
+            <a:r>
+              <a:rPr lang="en-US" sz="1100" b="1" dirty="0">
+                <a:solidFill>
+                  <a:srgbClr val="3B82F6"/>
+                </a:solidFill>
+                <a:latin typeface="Calibri" pitchFamily="34" charset="0"/>
+                <a:ea typeface="Calibri" pitchFamily="34" charset="-122"/>
+                <a:cs typeface="Calibri" pitchFamily="34" charset="-120"/>
+              </a:rPr>
+              <a:t>01</a:t>
+            </a:r>
+            <a:endParaRPr lang="en-US" sz="1100" dirty="0"/>
+          </a:p>
+        </p:txBody>
+      </p:sp>
+      <p:sp>
+        <p:nvSpPr>
+          <p:cNvPr id="12" name="Text 10">
+            <a:extLst>
+              <a:ext uri="{FF2B5EF4-FFF2-40B4-BE49-F238E27FC236}">
+                <a16:creationId xmlns:a16="http://schemas.microsoft.com/office/drawing/2014/main" id="{EC40E04E-C312-1013-FE9A-1A2D4E1F1446}"/>
+              </a:ext>
+            </a:extLst>
+          </p:cNvPr>
+          <p:cNvSpPr/>
+          <p:nvPr/>
+        </p:nvSpPr>
+        <p:spPr>
+          <a:xfrm>
+            <a:off x="1481320" y="3110865"/>
+            <a:ext cx="1417320" cy="457200"/>
+          </a:xfrm>
+          <a:prstGeom prst="rect">
+            <a:avLst/>
+          </a:prstGeom>
+          <a:noFill/>
+          <a:ln/>
+        </p:spPr>
+        <p:txBody>
+          <a:bodyPr wrap="square" rtlCol="0" anchor="ctr"/>
+          <a:lstStyle/>
+          <a:p>
+            <a:pPr marL="0" indent="0" algn="ctr">
+              <a:buNone/>
+            </a:pPr>
+            <a:r>
+              <a:rPr lang="en-US" sz="1200" b="1" dirty="0">
+                <a:solidFill>
+                  <a:srgbClr val="0F172A"/>
+                </a:solidFill>
+                <a:latin typeface="Calibri" pitchFamily="34" charset="0"/>
+                <a:ea typeface="Calibri" pitchFamily="34" charset="-122"/>
+                <a:cs typeface="Calibri" pitchFamily="34" charset="-120"/>
+              </a:rPr>
+              <a:t>Data Elements</a:t>
+            </a:r>
+            <a:endParaRPr lang="en-US" sz="1200" dirty="0"/>
+          </a:p>
+        </p:txBody>
+      </p:sp>
+      <p:sp>
+        <p:nvSpPr>
+          <p:cNvPr id="13" name="Text 11">
+            <a:extLst>
+              <a:ext uri="{FF2B5EF4-FFF2-40B4-BE49-F238E27FC236}">
+                <a16:creationId xmlns:a16="http://schemas.microsoft.com/office/drawing/2014/main" id="{81D23DD5-F3AB-C795-7929-3C4653AB5370}"/>
+              </a:ext>
+            </a:extLst>
+          </p:cNvPr>
+          <p:cNvSpPr/>
+          <p:nvPr/>
+        </p:nvSpPr>
+        <p:spPr>
+          <a:xfrm>
+            <a:off x="1481320" y="3659505"/>
+            <a:ext cx="1417320" cy="1481328"/>
+          </a:xfrm>
+          <a:prstGeom prst="rect">
+            <a:avLst/>
+          </a:prstGeom>
+          <a:noFill/>
+          <a:ln/>
+        </p:spPr>
+        <p:txBody>
+          <a:bodyPr wrap="square" rtlCol="0" anchor="ctr"/>
+          <a:lstStyle/>
+          <a:p>
+            <a:pPr marL="0" indent="0" algn="ctr">
+              <a:buNone/>
+            </a:pPr>
+            <a:r>
+              <a:rPr lang="en-US" sz="1000" dirty="0">
+                <a:solidFill>
+                  <a:srgbClr val="475569"/>
+                </a:solidFill>
+                <a:latin typeface="Calibri" pitchFamily="34" charset="0"/>
+                <a:ea typeface="Calibri" pitchFamily="34" charset="-122"/>
+                <a:cs typeface="Calibri" pitchFamily="34" charset="-120"/>
+              </a:rPr>
+              <a:t>Granular user attributes &amp; academic metrics</a:t>
+            </a:r>
+            <a:endParaRPr lang="en-US" sz="1000" dirty="0"/>
+          </a:p>
+        </p:txBody>
+      </p:sp>
+      <p:sp>
+        <p:nvSpPr>
+          <p:cNvPr id="14" name="Shape 12">
+            <a:extLst>
+              <a:ext uri="{FF2B5EF4-FFF2-40B4-BE49-F238E27FC236}">
+                <a16:creationId xmlns:a16="http://schemas.microsoft.com/office/drawing/2014/main" id="{5F85D61F-B191-430C-E244-9B75383DD30C}"/>
+              </a:ext>
+            </a:extLst>
+          </p:cNvPr>
+          <p:cNvSpPr/>
+          <p:nvPr/>
+        </p:nvSpPr>
+        <p:spPr>
+          <a:xfrm>
+            <a:off x="3127240" y="2013585"/>
+            <a:ext cx="1600200" cy="3310128"/>
+          </a:xfrm>
+          <a:prstGeom prst="roundRect">
+            <a:avLst>
+              <a:gd name="adj" fmla="val 6857"/>
+            </a:avLst>
+          </a:prstGeom>
+          <a:solidFill>
+            <a:srgbClr val="FFFFFF"/>
+          </a:solidFill>
+          <a:ln w="5080">
+            <a:solidFill>
+              <a:srgbClr val="E2E8F0"/>
+            </a:solidFill>
+            <a:prstDash val="solid"/>
+          </a:ln>
+          <a:effectLst>
+            <a:outerShdw blurRad="101600" dist="38100" dir="2700000" algn="bl" rotWithShape="0">
+              <a:srgbClr val="000000">
+                <a:alpha val="10000"/>
+              </a:srgbClr>
+            </a:outerShdw>
+          </a:effectLst>
+        </p:spPr>
+      </p:sp>
+      <p:sp>
+        <p:nvSpPr>
+          <p:cNvPr id="15" name="Shape 13">
+            <a:extLst>
+              <a:ext uri="{FF2B5EF4-FFF2-40B4-BE49-F238E27FC236}">
+                <a16:creationId xmlns:a16="http://schemas.microsoft.com/office/drawing/2014/main" id="{96BE99D7-5E55-33A1-A94B-F09FA364830B}"/>
+              </a:ext>
+            </a:extLst>
+          </p:cNvPr>
+          <p:cNvSpPr/>
+          <p:nvPr/>
+        </p:nvSpPr>
+        <p:spPr>
+          <a:xfrm>
+            <a:off x="3127240" y="2013585"/>
+            <a:ext cx="1600200" cy="347472"/>
+          </a:xfrm>
+          <a:prstGeom prst="roundRect">
+            <a:avLst>
+              <a:gd name="adj" fmla="val 31579"/>
+            </a:avLst>
+          </a:prstGeom>
+          <a:solidFill>
+            <a:srgbClr val="10B981"/>
+          </a:solidFill>
+          <a:ln w="12700">
+            <a:solidFill>
+              <a:srgbClr val="10B981"/>
+            </a:solidFill>
+            <a:prstDash val="solid"/>
+          </a:ln>
+        </p:spPr>
+      </p:sp>
+      <p:sp>
+        <p:nvSpPr>
+          <p:cNvPr id="16" name="Text 14">
+            <a:extLst>
+              <a:ext uri="{FF2B5EF4-FFF2-40B4-BE49-F238E27FC236}">
+                <a16:creationId xmlns:a16="http://schemas.microsoft.com/office/drawing/2014/main" id="{A459C445-D4E1-151E-C0A9-F1E6426FB7E5}"/>
+              </a:ext>
+            </a:extLst>
+          </p:cNvPr>
+          <p:cNvSpPr/>
+          <p:nvPr/>
+        </p:nvSpPr>
+        <p:spPr>
+          <a:xfrm>
+            <a:off x="3127240" y="2013585"/>
+            <a:ext cx="1600200" cy="347472"/>
+          </a:xfrm>
+          <a:prstGeom prst="rect">
+            <a:avLst/>
+          </a:prstGeom>
+          <a:noFill/>
+          <a:ln/>
+        </p:spPr>
+        <p:txBody>
+          <a:bodyPr wrap="square" lIns="0" tIns="0" rIns="0" bIns="0" rtlCol="0" anchor="ctr"/>
+          <a:lstStyle/>
+          <a:p>
+            <a:pPr marL="0" indent="0" algn="ctr">
+              <a:buNone/>
+            </a:pPr>
+            <a:r>
+              <a:rPr lang="en-US" sz="1400" b="1" dirty="0">
+                <a:solidFill>
+                  <a:srgbClr val="FFFFFF"/>
+                </a:solidFill>
+                <a:latin typeface="Calibri" pitchFamily="34" charset="0"/>
+                <a:ea typeface="Calibri" pitchFamily="34" charset="-122"/>
+                <a:cs typeface="Calibri" pitchFamily="34" charset="-120"/>
+              </a:rPr>
+              <a:t>02</a:t>
+            </a:r>
+            <a:endParaRPr lang="en-US" sz="1400" dirty="0"/>
+          </a:p>
+        </p:txBody>
+      </p:sp>
+      <p:sp>
+        <p:nvSpPr>
+          <p:cNvPr id="17" name="Shape 15">
+            <a:extLst>
+              <a:ext uri="{FF2B5EF4-FFF2-40B4-BE49-F238E27FC236}">
+                <a16:creationId xmlns:a16="http://schemas.microsoft.com/office/drawing/2014/main" id="{4678FBB8-2FBD-272C-521E-D83DB45F6C62}"/>
+              </a:ext>
+            </a:extLst>
+          </p:cNvPr>
+          <p:cNvSpPr/>
+          <p:nvPr/>
+        </p:nvSpPr>
+        <p:spPr>
+          <a:xfrm>
+            <a:off x="3703312" y="2525649"/>
+            <a:ext cx="457200" cy="457200"/>
+          </a:xfrm>
+          <a:prstGeom prst="ellipse">
+            <a:avLst/>
+          </a:prstGeom>
+          <a:solidFill>
+            <a:srgbClr val="10B981">
+              <a:alpha val="15000"/>
+            </a:srgbClr>
+          </a:solidFill>
+          <a:ln w="6350">
+            <a:solidFill>
+              <a:srgbClr val="10B981"/>
+            </a:solidFill>
+            <a:prstDash val="solid"/>
+          </a:ln>
+        </p:spPr>
+      </p:sp>
+      <p:sp>
+        <p:nvSpPr>
+          <p:cNvPr id="18" name="Text 16">
+            <a:extLst>
+              <a:ext uri="{FF2B5EF4-FFF2-40B4-BE49-F238E27FC236}">
+                <a16:creationId xmlns:a16="http://schemas.microsoft.com/office/drawing/2014/main" id="{AB77CD51-A0CF-814A-06A2-BA6CB1F5CB6A}"/>
+              </a:ext>
+            </a:extLst>
+          </p:cNvPr>
+          <p:cNvSpPr/>
+          <p:nvPr/>
+        </p:nvSpPr>
+        <p:spPr>
+          <a:xfrm>
+            <a:off x="3703312" y="2525649"/>
+            <a:ext cx="457200" cy="457200"/>
+          </a:xfrm>
+          <a:prstGeom prst="rect">
+            <a:avLst/>
+          </a:prstGeom>
+          <a:noFill/>
+          <a:ln/>
+        </p:spPr>
+        <p:txBody>
+          <a:bodyPr wrap="square" lIns="0" tIns="0" rIns="0" bIns="0" rtlCol="0" anchor="ctr"/>
+          <a:lstStyle/>
+          <a:p>
+            <a:pPr marL="0" indent="0" algn="ctr">
+              <a:buNone/>
+            </a:pPr>
+            <a:r>
+              <a:rPr lang="en-US" sz="1100" b="1" dirty="0">
+                <a:solidFill>
+                  <a:srgbClr val="10B981"/>
+                </a:solidFill>
+                <a:latin typeface="Calibri" pitchFamily="34" charset="0"/>
+                <a:ea typeface="Calibri" pitchFamily="34" charset="-122"/>
+                <a:cs typeface="Calibri" pitchFamily="34" charset="-120"/>
+              </a:rPr>
+              <a:t>02</a:t>
+            </a:r>
+            <a:endParaRPr lang="en-US" sz="1100" dirty="0"/>
+          </a:p>
+        </p:txBody>
+      </p:sp>
+      <p:sp>
+        <p:nvSpPr>
+          <p:cNvPr id="19" name="Text 17">
+            <a:extLst>
+              <a:ext uri="{FF2B5EF4-FFF2-40B4-BE49-F238E27FC236}">
+                <a16:creationId xmlns:a16="http://schemas.microsoft.com/office/drawing/2014/main" id="{C57DA0F7-03F7-90F9-5DBE-6BF5F54BF3A0}"/>
+              </a:ext>
+            </a:extLst>
+          </p:cNvPr>
+          <p:cNvSpPr/>
+          <p:nvPr/>
+        </p:nvSpPr>
+        <p:spPr>
+          <a:xfrm>
+            <a:off x="3218680" y="3110865"/>
+            <a:ext cx="1417320" cy="457200"/>
+          </a:xfrm>
+          <a:prstGeom prst="rect">
+            <a:avLst/>
+          </a:prstGeom>
+          <a:noFill/>
+          <a:ln/>
+        </p:spPr>
+        <p:txBody>
+          <a:bodyPr wrap="square" rtlCol="0" anchor="ctr"/>
+          <a:lstStyle/>
+          <a:p>
+            <a:pPr marL="0" indent="0" algn="ctr">
+              <a:buNone/>
+            </a:pPr>
+            <a:r>
+              <a:rPr lang="en-US" sz="1200" b="1" dirty="0">
+                <a:solidFill>
+                  <a:srgbClr val="0F172A"/>
+                </a:solidFill>
+                <a:latin typeface="Calibri" pitchFamily="34" charset="0"/>
+                <a:ea typeface="Calibri" pitchFamily="34" charset="-122"/>
+                <a:cs typeface="Calibri" pitchFamily="34" charset="-120"/>
+              </a:rPr>
+              <a:t>Conceptual Design</a:t>
+            </a:r>
+            <a:endParaRPr lang="en-US" sz="1200" dirty="0"/>
+          </a:p>
+        </p:txBody>
+      </p:sp>
+      <p:sp>
+        <p:nvSpPr>
+          <p:cNvPr id="20" name="Text 18">
+            <a:extLst>
+              <a:ext uri="{FF2B5EF4-FFF2-40B4-BE49-F238E27FC236}">
+                <a16:creationId xmlns:a16="http://schemas.microsoft.com/office/drawing/2014/main" id="{D860BF02-1B50-A3E4-E458-679AD51F582E}"/>
+              </a:ext>
+            </a:extLst>
+          </p:cNvPr>
+          <p:cNvSpPr/>
+          <p:nvPr/>
+        </p:nvSpPr>
+        <p:spPr>
+          <a:xfrm>
+            <a:off x="3218680" y="3659505"/>
+            <a:ext cx="1417320" cy="1481328"/>
+          </a:xfrm>
+          <a:prstGeom prst="rect">
+            <a:avLst/>
+          </a:prstGeom>
+          <a:noFill/>
+          <a:ln/>
+        </p:spPr>
+        <p:txBody>
+          <a:bodyPr wrap="square" rtlCol="0" anchor="ctr"/>
+          <a:lstStyle/>
+          <a:p>
+            <a:pPr marL="0" indent="0" algn="ctr">
+              <a:buNone/>
+            </a:pPr>
+            <a:r>
+              <a:rPr lang="en-US" sz="1000" dirty="0">
+                <a:solidFill>
+                  <a:srgbClr val="475569"/>
+                </a:solidFill>
+                <a:latin typeface="Calibri" pitchFamily="34" charset="0"/>
+                <a:ea typeface="Calibri" pitchFamily="34" charset="-122"/>
+                <a:cs typeface="Calibri" pitchFamily="34" charset="-120"/>
+              </a:rPr>
+              <a:t>Relational model blueprint &amp; 3NF normalisation</a:t>
+            </a:r>
+            <a:endParaRPr lang="en-US" sz="1000" dirty="0"/>
+          </a:p>
+        </p:txBody>
+      </p:sp>
+      <p:sp>
+        <p:nvSpPr>
+          <p:cNvPr id="21" name="Shape 19">
+            <a:extLst>
+              <a:ext uri="{FF2B5EF4-FFF2-40B4-BE49-F238E27FC236}">
+                <a16:creationId xmlns:a16="http://schemas.microsoft.com/office/drawing/2014/main" id="{317109E9-E3A3-C3D3-744F-AACA99EE73C5}"/>
+              </a:ext>
+            </a:extLst>
+          </p:cNvPr>
+          <p:cNvSpPr/>
+          <p:nvPr/>
+        </p:nvSpPr>
+        <p:spPr>
+          <a:xfrm>
+            <a:off x="4864600" y="2013585"/>
+            <a:ext cx="1600200" cy="3310128"/>
+          </a:xfrm>
+          <a:prstGeom prst="roundRect">
+            <a:avLst>
+              <a:gd name="adj" fmla="val 6857"/>
+            </a:avLst>
+          </a:prstGeom>
+          <a:solidFill>
+            <a:srgbClr val="FFFFFF"/>
+          </a:solidFill>
+          <a:ln w="5080">
+            <a:solidFill>
+              <a:srgbClr val="E2E8F0"/>
+            </a:solidFill>
+            <a:prstDash val="solid"/>
+          </a:ln>
+          <a:effectLst>
+            <a:outerShdw blurRad="101600" dist="38100" dir="2700000" algn="bl" rotWithShape="0">
+              <a:srgbClr val="000000">
+                <a:alpha val="10000"/>
+              </a:srgbClr>
+            </a:outerShdw>
+          </a:effectLst>
+        </p:spPr>
+      </p:sp>
+      <p:sp>
+        <p:nvSpPr>
+          <p:cNvPr id="22" name="Shape 20">
+            <a:extLst>
+              <a:ext uri="{FF2B5EF4-FFF2-40B4-BE49-F238E27FC236}">
+                <a16:creationId xmlns:a16="http://schemas.microsoft.com/office/drawing/2014/main" id="{06E0EC94-F753-13EE-F44A-B664D404AE52}"/>
+              </a:ext>
+            </a:extLst>
+          </p:cNvPr>
+          <p:cNvSpPr/>
+          <p:nvPr/>
+        </p:nvSpPr>
+        <p:spPr>
+          <a:xfrm>
+            <a:off x="4864600" y="2013585"/>
+            <a:ext cx="1600200" cy="347472"/>
+          </a:xfrm>
+          <a:prstGeom prst="roundRect">
+            <a:avLst>
+              <a:gd name="adj" fmla="val 31579"/>
+            </a:avLst>
+          </a:prstGeom>
+          <a:solidFill>
+            <a:srgbClr val="F59E0B"/>
+          </a:solidFill>
+          <a:ln w="12700">
+            <a:solidFill>
+              <a:srgbClr val="F59E0B"/>
+            </a:solidFill>
+            <a:prstDash val="solid"/>
+          </a:ln>
+        </p:spPr>
+      </p:sp>
+      <p:sp>
+        <p:nvSpPr>
+          <p:cNvPr id="23" name="Text 21">
+            <a:extLst>
+              <a:ext uri="{FF2B5EF4-FFF2-40B4-BE49-F238E27FC236}">
+                <a16:creationId xmlns:a16="http://schemas.microsoft.com/office/drawing/2014/main" id="{2FBCC454-ED28-7027-87B3-EB75F4172A24}"/>
+              </a:ext>
+            </a:extLst>
+          </p:cNvPr>
+          <p:cNvSpPr/>
+          <p:nvPr/>
+        </p:nvSpPr>
+        <p:spPr>
+          <a:xfrm>
+            <a:off x="4864600" y="2013585"/>
+            <a:ext cx="1600200" cy="347472"/>
+          </a:xfrm>
+          <a:prstGeom prst="rect">
+            <a:avLst/>
+          </a:prstGeom>
+          <a:noFill/>
+          <a:ln/>
+        </p:spPr>
+        <p:txBody>
+          <a:bodyPr wrap="square" lIns="0" tIns="0" rIns="0" bIns="0" rtlCol="0" anchor="ctr"/>
+          <a:lstStyle/>
+          <a:p>
+            <a:pPr marL="0" indent="0" algn="ctr">
+              <a:buNone/>
+            </a:pPr>
+            <a:r>
+              <a:rPr lang="en-US" sz="1400" b="1" dirty="0">
+                <a:solidFill>
+                  <a:srgbClr val="FFFFFF"/>
+                </a:solidFill>
+                <a:latin typeface="Calibri" pitchFamily="34" charset="0"/>
+                <a:ea typeface="Calibri" pitchFamily="34" charset="-122"/>
+                <a:cs typeface="Calibri" pitchFamily="34" charset="-120"/>
+              </a:rPr>
+              <a:t>03</a:t>
+            </a:r>
+            <a:endParaRPr lang="en-US" sz="1400" dirty="0"/>
+          </a:p>
+        </p:txBody>
+      </p:sp>
+      <p:sp>
+        <p:nvSpPr>
+          <p:cNvPr id="24" name="Shape 22">
+            <a:extLst>
+              <a:ext uri="{FF2B5EF4-FFF2-40B4-BE49-F238E27FC236}">
+                <a16:creationId xmlns:a16="http://schemas.microsoft.com/office/drawing/2014/main" id="{FE4F73A9-94CB-1F51-FB42-2D004A5AE8A8}"/>
+              </a:ext>
+            </a:extLst>
+          </p:cNvPr>
+          <p:cNvSpPr/>
+          <p:nvPr/>
+        </p:nvSpPr>
+        <p:spPr>
+          <a:xfrm>
+            <a:off x="5440672" y="2525649"/>
+            <a:ext cx="457200" cy="457200"/>
+          </a:xfrm>
+          <a:prstGeom prst="ellipse">
+            <a:avLst/>
+          </a:prstGeom>
+          <a:solidFill>
+            <a:srgbClr val="F59E0B">
+              <a:alpha val="15000"/>
+            </a:srgbClr>
+          </a:solidFill>
+          <a:ln w="6350">
+            <a:solidFill>
+              <a:srgbClr val="F59E0B"/>
+            </a:solidFill>
+            <a:prstDash val="solid"/>
+          </a:ln>
+        </p:spPr>
+      </p:sp>
+      <p:sp>
+        <p:nvSpPr>
+          <p:cNvPr id="25" name="Text 23">
+            <a:extLst>
+              <a:ext uri="{FF2B5EF4-FFF2-40B4-BE49-F238E27FC236}">
+                <a16:creationId xmlns:a16="http://schemas.microsoft.com/office/drawing/2014/main" id="{5FD7F3EE-24FB-EE59-8F7C-49B9862C18F7}"/>
+              </a:ext>
+            </a:extLst>
+          </p:cNvPr>
+          <p:cNvSpPr/>
+          <p:nvPr/>
+        </p:nvSpPr>
+        <p:spPr>
+          <a:xfrm>
+            <a:off x="5440672" y="2525649"/>
+            <a:ext cx="457200" cy="457200"/>
+          </a:xfrm>
+          <a:prstGeom prst="rect">
+            <a:avLst/>
+          </a:prstGeom>
+          <a:noFill/>
+          <a:ln/>
+        </p:spPr>
+        <p:txBody>
+          <a:bodyPr wrap="square" lIns="0" tIns="0" rIns="0" bIns="0" rtlCol="0" anchor="ctr"/>
+          <a:lstStyle/>
+          <a:p>
+            <a:pPr marL="0" indent="0" algn="ctr">
+              <a:buNone/>
+            </a:pPr>
+            <a:r>
+              <a:rPr lang="en-US" sz="1100" b="1" dirty="0">
+                <a:solidFill>
+                  <a:srgbClr val="F59E0B"/>
+                </a:solidFill>
+                <a:latin typeface="Calibri" pitchFamily="34" charset="0"/>
+                <a:ea typeface="Calibri" pitchFamily="34" charset="-122"/>
+                <a:cs typeface="Calibri" pitchFamily="34" charset="-120"/>
+              </a:rPr>
+              <a:t>03</a:t>
+            </a:r>
+            <a:endParaRPr lang="en-US" sz="1100" dirty="0"/>
+          </a:p>
+        </p:txBody>
+      </p:sp>
+      <p:sp>
+        <p:nvSpPr>
+          <p:cNvPr id="26" name="Text 24">
+            <a:extLst>
+              <a:ext uri="{FF2B5EF4-FFF2-40B4-BE49-F238E27FC236}">
+                <a16:creationId xmlns:a16="http://schemas.microsoft.com/office/drawing/2014/main" id="{C08F3025-702C-1023-0F5D-0E011BB48B86}"/>
+              </a:ext>
+            </a:extLst>
+          </p:cNvPr>
+          <p:cNvSpPr/>
+          <p:nvPr/>
+        </p:nvSpPr>
+        <p:spPr>
+          <a:xfrm>
+            <a:off x="4956040" y="3110865"/>
+            <a:ext cx="1417320" cy="457200"/>
+          </a:xfrm>
+          <a:prstGeom prst="rect">
+            <a:avLst/>
+          </a:prstGeom>
+          <a:noFill/>
+          <a:ln/>
+        </p:spPr>
+        <p:txBody>
+          <a:bodyPr wrap="square" rtlCol="0" anchor="ctr"/>
+          <a:lstStyle/>
+          <a:p>
+            <a:pPr marL="0" indent="0" algn="ctr">
+              <a:buNone/>
+            </a:pPr>
+            <a:r>
+              <a:rPr lang="en-US" sz="1200" b="1" dirty="0">
+                <a:solidFill>
+                  <a:srgbClr val="0F172A"/>
+                </a:solidFill>
+                <a:latin typeface="Calibri" pitchFamily="34" charset="0"/>
+                <a:ea typeface="Calibri" pitchFamily="34" charset="-122"/>
+                <a:cs typeface="Calibri" pitchFamily="34" charset="-120"/>
+              </a:rPr>
+              <a:t>ER Diagram</a:t>
+            </a:r>
+            <a:endParaRPr lang="en-US" sz="1200" dirty="0"/>
+          </a:p>
+        </p:txBody>
+      </p:sp>
+      <p:sp>
+        <p:nvSpPr>
+          <p:cNvPr id="27" name="Text 25">
+            <a:extLst>
+              <a:ext uri="{FF2B5EF4-FFF2-40B4-BE49-F238E27FC236}">
+                <a16:creationId xmlns:a16="http://schemas.microsoft.com/office/drawing/2014/main" id="{473D2DA8-F7E7-B8EE-E7FD-88B0ADB69859}"/>
+              </a:ext>
+            </a:extLst>
+          </p:cNvPr>
+          <p:cNvSpPr/>
+          <p:nvPr/>
+        </p:nvSpPr>
+        <p:spPr>
+          <a:xfrm>
+            <a:off x="4956040" y="3659505"/>
+            <a:ext cx="1417320" cy="1481328"/>
+          </a:xfrm>
+          <a:prstGeom prst="rect">
+            <a:avLst/>
+          </a:prstGeom>
+          <a:noFill/>
+          <a:ln/>
+        </p:spPr>
+        <p:txBody>
+          <a:bodyPr wrap="square" rtlCol="0" anchor="ctr"/>
+          <a:lstStyle/>
+          <a:p>
+            <a:pPr marL="0" indent="0" algn="ctr">
+              <a:buNone/>
+            </a:pPr>
+            <a:r>
+              <a:rPr lang="en-US" sz="1000" dirty="0">
+                <a:solidFill>
+                  <a:srgbClr val="475569"/>
+                </a:solidFill>
+                <a:latin typeface="Calibri" pitchFamily="34" charset="0"/>
+                <a:ea typeface="Calibri" pitchFamily="34" charset="-122"/>
+                <a:cs typeface="Calibri" pitchFamily="34" charset="-120"/>
+              </a:rPr>
+              <a:t>Entity dependencies, constraints &amp; cardinalities</a:t>
+            </a:r>
+            <a:endParaRPr lang="en-US" sz="1000" dirty="0"/>
+          </a:p>
+        </p:txBody>
+      </p:sp>
+      <p:sp>
+        <p:nvSpPr>
+          <p:cNvPr id="28" name="Shape 26">
+            <a:extLst>
+              <a:ext uri="{FF2B5EF4-FFF2-40B4-BE49-F238E27FC236}">
+                <a16:creationId xmlns:a16="http://schemas.microsoft.com/office/drawing/2014/main" id="{5A8C36C8-7E11-7390-8A62-B27B7594AD38}"/>
+              </a:ext>
+            </a:extLst>
+          </p:cNvPr>
+          <p:cNvSpPr/>
+          <p:nvPr/>
+        </p:nvSpPr>
+        <p:spPr>
+          <a:xfrm>
+            <a:off x="6601960" y="2013585"/>
+            <a:ext cx="1600200" cy="3310128"/>
+          </a:xfrm>
+          <a:prstGeom prst="roundRect">
+            <a:avLst>
+              <a:gd name="adj" fmla="val 6857"/>
+            </a:avLst>
+          </a:prstGeom>
+          <a:solidFill>
+            <a:srgbClr val="FFFFFF"/>
+          </a:solidFill>
+          <a:ln w="5080">
+            <a:solidFill>
+              <a:srgbClr val="E2E8F0"/>
+            </a:solidFill>
+            <a:prstDash val="solid"/>
+          </a:ln>
+          <a:effectLst>
+            <a:outerShdw blurRad="101600" dist="38100" dir="2700000" algn="bl" rotWithShape="0">
+              <a:srgbClr val="000000">
+                <a:alpha val="10000"/>
+              </a:srgbClr>
+            </a:outerShdw>
+          </a:effectLst>
+        </p:spPr>
+      </p:sp>
+      <p:sp>
+        <p:nvSpPr>
+          <p:cNvPr id="29" name="Shape 27">
+            <a:extLst>
+              <a:ext uri="{FF2B5EF4-FFF2-40B4-BE49-F238E27FC236}">
+                <a16:creationId xmlns:a16="http://schemas.microsoft.com/office/drawing/2014/main" id="{A22DF681-E046-6F2B-F99D-73E394D848D7}"/>
+              </a:ext>
+            </a:extLst>
+          </p:cNvPr>
+          <p:cNvSpPr/>
+          <p:nvPr/>
+        </p:nvSpPr>
+        <p:spPr>
+          <a:xfrm>
+            <a:off x="6601960" y="2013585"/>
+            <a:ext cx="1600200" cy="347472"/>
+          </a:xfrm>
+          <a:prstGeom prst="roundRect">
+            <a:avLst>
+              <a:gd name="adj" fmla="val 31579"/>
+            </a:avLst>
+          </a:prstGeom>
+          <a:solidFill>
+            <a:srgbClr val="64748B"/>
+          </a:solidFill>
+          <a:ln w="12700">
+            <a:solidFill>
+              <a:srgbClr val="64748B"/>
+            </a:solidFill>
+            <a:prstDash val="solid"/>
+          </a:ln>
+        </p:spPr>
+      </p:sp>
+      <p:sp>
+        <p:nvSpPr>
+          <p:cNvPr id="30" name="Text 28">
+            <a:extLst>
+              <a:ext uri="{FF2B5EF4-FFF2-40B4-BE49-F238E27FC236}">
+                <a16:creationId xmlns:a16="http://schemas.microsoft.com/office/drawing/2014/main" id="{2FB2D681-3EC0-3649-7B40-17B29947BAD7}"/>
+              </a:ext>
+            </a:extLst>
+          </p:cNvPr>
+          <p:cNvSpPr/>
+          <p:nvPr/>
+        </p:nvSpPr>
+        <p:spPr>
+          <a:xfrm>
+            <a:off x="6601960" y="2013585"/>
+            <a:ext cx="1600200" cy="347472"/>
+          </a:xfrm>
+          <a:prstGeom prst="rect">
+            <a:avLst/>
+          </a:prstGeom>
+          <a:noFill/>
+          <a:ln/>
+        </p:spPr>
+        <p:txBody>
+          <a:bodyPr wrap="square" lIns="0" tIns="0" rIns="0" bIns="0" rtlCol="0" anchor="ctr"/>
+          <a:lstStyle/>
+          <a:p>
+            <a:pPr marL="0" indent="0" algn="ctr">
+              <a:buNone/>
+            </a:pPr>
+            <a:r>
+              <a:rPr lang="en-US" sz="1400" b="1" dirty="0">
+                <a:solidFill>
+                  <a:srgbClr val="FFFFFF"/>
+                </a:solidFill>
+                <a:latin typeface="Calibri" pitchFamily="34" charset="0"/>
+                <a:ea typeface="Calibri" pitchFamily="34" charset="-122"/>
+                <a:cs typeface="Calibri" pitchFamily="34" charset="-120"/>
+              </a:rPr>
+              <a:t>04</a:t>
+            </a:r>
+            <a:endParaRPr lang="en-US" sz="1400" dirty="0"/>
+          </a:p>
+        </p:txBody>
+      </p:sp>
+      <p:sp>
+        <p:nvSpPr>
+          <p:cNvPr id="31" name="Shape 29">
+            <a:extLst>
+              <a:ext uri="{FF2B5EF4-FFF2-40B4-BE49-F238E27FC236}">
+                <a16:creationId xmlns:a16="http://schemas.microsoft.com/office/drawing/2014/main" id="{6A8CC6DF-F397-F537-896C-5D78A7BD8100}"/>
+              </a:ext>
+            </a:extLst>
+          </p:cNvPr>
+          <p:cNvSpPr/>
+          <p:nvPr/>
+        </p:nvSpPr>
+        <p:spPr>
+          <a:xfrm>
+            <a:off x="7178032" y="2525649"/>
+            <a:ext cx="457200" cy="457200"/>
+          </a:xfrm>
+          <a:prstGeom prst="ellipse">
+            <a:avLst/>
+          </a:prstGeom>
+          <a:solidFill>
+            <a:srgbClr val="64748B">
+              <a:alpha val="15000"/>
+            </a:srgbClr>
+          </a:solidFill>
+          <a:ln w="6350">
+            <a:solidFill>
+              <a:srgbClr val="64748B"/>
+            </a:solidFill>
+            <a:prstDash val="solid"/>
+          </a:ln>
+        </p:spPr>
+      </p:sp>
+      <p:sp>
+        <p:nvSpPr>
+          <p:cNvPr id="32" name="Text 30">
+            <a:extLst>
+              <a:ext uri="{FF2B5EF4-FFF2-40B4-BE49-F238E27FC236}">
+                <a16:creationId xmlns:a16="http://schemas.microsoft.com/office/drawing/2014/main" id="{7491F938-B92D-E930-B87E-90A209D60F3D}"/>
+              </a:ext>
+            </a:extLst>
+          </p:cNvPr>
+          <p:cNvSpPr/>
+          <p:nvPr/>
+        </p:nvSpPr>
+        <p:spPr>
+          <a:xfrm>
+            <a:off x="7178032" y="2525649"/>
+            <a:ext cx="457200" cy="457200"/>
+          </a:xfrm>
+          <a:prstGeom prst="rect">
+            <a:avLst/>
+          </a:prstGeom>
+          <a:noFill/>
+          <a:ln/>
+        </p:spPr>
+        <p:txBody>
+          <a:bodyPr wrap="square" lIns="0" tIns="0" rIns="0" bIns="0" rtlCol="0" anchor="ctr"/>
+          <a:lstStyle/>
+          <a:p>
+            <a:pPr marL="0" indent="0" algn="ctr">
+              <a:buNone/>
+            </a:pPr>
+            <a:r>
+              <a:rPr lang="en-US" sz="1100" b="1" dirty="0">
+                <a:solidFill>
+                  <a:srgbClr val="64748B"/>
+                </a:solidFill>
+                <a:latin typeface="Calibri" pitchFamily="34" charset="0"/>
+                <a:ea typeface="Calibri" pitchFamily="34" charset="-122"/>
+                <a:cs typeface="Calibri" pitchFamily="34" charset="-120"/>
+              </a:rPr>
+              <a:t>04</a:t>
+            </a:r>
+            <a:endParaRPr lang="en-US" sz="1100" dirty="0"/>
+          </a:p>
+        </p:txBody>
+      </p:sp>
+      <p:sp>
+        <p:nvSpPr>
+          <p:cNvPr id="33" name="Text 31">
+            <a:extLst>
+              <a:ext uri="{FF2B5EF4-FFF2-40B4-BE49-F238E27FC236}">
+                <a16:creationId xmlns:a16="http://schemas.microsoft.com/office/drawing/2014/main" id="{E36A09D0-57CB-A6B1-C140-C8A9C871B4AC}"/>
+              </a:ext>
+            </a:extLst>
+          </p:cNvPr>
+          <p:cNvSpPr/>
+          <p:nvPr/>
+        </p:nvSpPr>
+        <p:spPr>
+          <a:xfrm>
+            <a:off x="6693400" y="3110865"/>
+            <a:ext cx="1417320" cy="457200"/>
+          </a:xfrm>
+          <a:prstGeom prst="rect">
+            <a:avLst/>
+          </a:prstGeom>
+          <a:noFill/>
+          <a:ln/>
+        </p:spPr>
+        <p:txBody>
+          <a:bodyPr wrap="square" rtlCol="0" anchor="ctr"/>
+          <a:lstStyle/>
+          <a:p>
+            <a:pPr marL="0" indent="0" algn="ctr">
+              <a:buNone/>
+            </a:pPr>
+            <a:r>
+              <a:rPr lang="en-US" sz="1200" b="1" dirty="0">
+                <a:solidFill>
+                  <a:srgbClr val="0F172A"/>
+                </a:solidFill>
+                <a:latin typeface="Calibri" pitchFamily="34" charset="0"/>
+                <a:ea typeface="Calibri" pitchFamily="34" charset="-122"/>
+                <a:cs typeface="Calibri" pitchFamily="34" charset="-120"/>
+              </a:rPr>
+              <a:t>DB &amp; Backend</a:t>
+            </a:r>
+            <a:endParaRPr lang="en-US" sz="1200" dirty="0"/>
+          </a:p>
+        </p:txBody>
+      </p:sp>
+      <p:sp>
+        <p:nvSpPr>
+          <p:cNvPr id="34" name="Text 32">
+            <a:extLst>
+              <a:ext uri="{FF2B5EF4-FFF2-40B4-BE49-F238E27FC236}">
+                <a16:creationId xmlns:a16="http://schemas.microsoft.com/office/drawing/2014/main" id="{B769A987-1358-2EEC-309A-31B821F668DA}"/>
+              </a:ext>
+            </a:extLst>
+          </p:cNvPr>
+          <p:cNvSpPr/>
+          <p:nvPr/>
+        </p:nvSpPr>
+        <p:spPr>
+          <a:xfrm>
+            <a:off x="6693400" y="3659505"/>
+            <a:ext cx="1417320" cy="1481328"/>
+          </a:xfrm>
+          <a:prstGeom prst="rect">
+            <a:avLst/>
+          </a:prstGeom>
+          <a:noFill/>
+          <a:ln/>
+        </p:spPr>
+        <p:txBody>
+          <a:bodyPr wrap="square" rtlCol="0" anchor="ctr"/>
+          <a:lstStyle/>
+          <a:p>
+            <a:pPr marL="0" indent="0" algn="ctr">
+              <a:buNone/>
+            </a:pPr>
+            <a:r>
+              <a:rPr lang="en-US" sz="1000" dirty="0">
+                <a:solidFill>
+                  <a:srgbClr val="475569"/>
+                </a:solidFill>
+                <a:latin typeface="Calibri" pitchFamily="34" charset="0"/>
+                <a:ea typeface="Calibri" pitchFamily="34" charset="-122"/>
+                <a:cs typeface="Calibri" pitchFamily="34" charset="-120"/>
+              </a:rPr>
+              <a:t>PostgreSQL schemas &amp; Express API server</a:t>
+            </a:r>
+            <a:endParaRPr lang="en-US" sz="1000" dirty="0"/>
+          </a:p>
+        </p:txBody>
+      </p:sp>
+      <p:sp>
+        <p:nvSpPr>
+          <p:cNvPr id="35" name="Shape 33">
+            <a:extLst>
+              <a:ext uri="{FF2B5EF4-FFF2-40B4-BE49-F238E27FC236}">
+                <a16:creationId xmlns:a16="http://schemas.microsoft.com/office/drawing/2014/main" id="{BE6495B9-D26A-E7BD-9D2A-F294ECCB88ED}"/>
+              </a:ext>
+            </a:extLst>
+          </p:cNvPr>
+          <p:cNvSpPr/>
+          <p:nvPr/>
+        </p:nvSpPr>
+        <p:spPr>
+          <a:xfrm>
+            <a:off x="8339320" y="2013585"/>
+            <a:ext cx="1600200" cy="3310128"/>
+          </a:xfrm>
+          <a:prstGeom prst="roundRect">
+            <a:avLst>
+              <a:gd name="adj" fmla="val 6857"/>
+            </a:avLst>
+          </a:prstGeom>
+          <a:solidFill>
+            <a:srgbClr val="FFFFFF"/>
+          </a:solidFill>
+          <a:ln w="5080">
+            <a:solidFill>
+              <a:srgbClr val="E2E8F0"/>
+            </a:solidFill>
+            <a:prstDash val="solid"/>
+          </a:ln>
+          <a:effectLst>
+            <a:outerShdw blurRad="101600" dist="38100" dir="2700000" algn="bl" rotWithShape="0">
+              <a:srgbClr val="000000">
+                <a:alpha val="10000"/>
+              </a:srgbClr>
+            </a:outerShdw>
+          </a:effectLst>
+        </p:spPr>
+      </p:sp>
+      <p:sp>
+        <p:nvSpPr>
+          <p:cNvPr id="36" name="Shape 34">
+            <a:extLst>
+              <a:ext uri="{FF2B5EF4-FFF2-40B4-BE49-F238E27FC236}">
+                <a16:creationId xmlns:a16="http://schemas.microsoft.com/office/drawing/2014/main" id="{861D73F0-0840-ECB0-1F5D-529DA4B7DC17}"/>
+              </a:ext>
+            </a:extLst>
+          </p:cNvPr>
+          <p:cNvSpPr/>
+          <p:nvPr/>
+        </p:nvSpPr>
+        <p:spPr>
+          <a:xfrm>
+            <a:off x="8339320" y="2013585"/>
+            <a:ext cx="1600200" cy="347472"/>
+          </a:xfrm>
+          <a:prstGeom prst="roundRect">
+            <a:avLst>
+              <a:gd name="adj" fmla="val 31579"/>
+            </a:avLst>
+          </a:prstGeom>
+          <a:solidFill>
+            <a:srgbClr val="3B82F6"/>
+          </a:solidFill>
+          <a:ln w="12700">
+            <a:solidFill>
+              <a:srgbClr val="3B82F6"/>
+            </a:solidFill>
+            <a:prstDash val="solid"/>
+          </a:ln>
+        </p:spPr>
+      </p:sp>
+      <p:sp>
+        <p:nvSpPr>
+          <p:cNvPr id="37" name="Text 35">
+            <a:extLst>
+              <a:ext uri="{FF2B5EF4-FFF2-40B4-BE49-F238E27FC236}">
+                <a16:creationId xmlns:a16="http://schemas.microsoft.com/office/drawing/2014/main" id="{82231B4D-BC2F-3B72-0DCB-D3194CCA86A4}"/>
+              </a:ext>
+            </a:extLst>
+          </p:cNvPr>
+          <p:cNvSpPr/>
+          <p:nvPr/>
+        </p:nvSpPr>
+        <p:spPr>
+          <a:xfrm>
+            <a:off x="8339320" y="2013585"/>
+            <a:ext cx="1600200" cy="347472"/>
+          </a:xfrm>
+          <a:prstGeom prst="rect">
+            <a:avLst/>
+          </a:prstGeom>
+          <a:noFill/>
+          <a:ln/>
+        </p:spPr>
+        <p:txBody>
+          <a:bodyPr wrap="square" lIns="0" tIns="0" rIns="0" bIns="0" rtlCol="0" anchor="ctr"/>
+          <a:lstStyle/>
+          <a:p>
+            <a:pPr marL="0" indent="0" algn="ctr">
+              <a:buNone/>
+            </a:pPr>
+            <a:r>
+              <a:rPr lang="en-US" sz="1400" b="1" dirty="0">
+                <a:solidFill>
+                  <a:srgbClr val="FFFFFF"/>
+                </a:solidFill>
+                <a:latin typeface="Calibri" pitchFamily="34" charset="0"/>
+                <a:ea typeface="Calibri" pitchFamily="34" charset="-122"/>
+                <a:cs typeface="Calibri" pitchFamily="34" charset="-120"/>
+              </a:rPr>
+              <a:t>05</a:t>
+            </a:r>
+            <a:endParaRPr lang="en-US" sz="1400" dirty="0"/>
+          </a:p>
+        </p:txBody>
+      </p:sp>
+      <p:sp>
+        <p:nvSpPr>
+          <p:cNvPr id="38" name="Shape 36">
+            <a:extLst>
+              <a:ext uri="{FF2B5EF4-FFF2-40B4-BE49-F238E27FC236}">
+                <a16:creationId xmlns:a16="http://schemas.microsoft.com/office/drawing/2014/main" id="{8999220D-F928-B08C-A956-D20D37F2943C}"/>
+              </a:ext>
+            </a:extLst>
+          </p:cNvPr>
+          <p:cNvSpPr/>
+          <p:nvPr/>
+        </p:nvSpPr>
+        <p:spPr>
+          <a:xfrm>
+            <a:off x="8915392" y="2525649"/>
+            <a:ext cx="457200" cy="457200"/>
+          </a:xfrm>
+          <a:prstGeom prst="ellipse">
+            <a:avLst/>
+          </a:prstGeom>
+          <a:solidFill>
+            <a:srgbClr val="3B82F6">
+              <a:alpha val="15000"/>
+            </a:srgbClr>
+          </a:solidFill>
+          <a:ln w="6350">
+            <a:solidFill>
+              <a:srgbClr val="3B82F6"/>
+            </a:solidFill>
+            <a:prstDash val="solid"/>
+          </a:ln>
+        </p:spPr>
+      </p:sp>
+      <p:sp>
+        <p:nvSpPr>
+          <p:cNvPr id="39" name="Text 37">
+            <a:extLst>
+              <a:ext uri="{FF2B5EF4-FFF2-40B4-BE49-F238E27FC236}">
+                <a16:creationId xmlns:a16="http://schemas.microsoft.com/office/drawing/2014/main" id="{DFEF93B0-F866-C2D6-33EA-730B7866892B}"/>
+              </a:ext>
+            </a:extLst>
+          </p:cNvPr>
+          <p:cNvSpPr/>
+          <p:nvPr/>
+        </p:nvSpPr>
+        <p:spPr>
+          <a:xfrm>
+            <a:off x="8915392" y="2525649"/>
+            <a:ext cx="457200" cy="457200"/>
+          </a:xfrm>
+          <a:prstGeom prst="rect">
+            <a:avLst/>
+          </a:prstGeom>
+          <a:noFill/>
+          <a:ln/>
+        </p:spPr>
+        <p:txBody>
+          <a:bodyPr wrap="square" lIns="0" tIns="0" rIns="0" bIns="0" rtlCol="0" anchor="ctr"/>
+          <a:lstStyle/>
+          <a:p>
+            <a:pPr marL="0" indent="0" algn="ctr">
+              <a:buNone/>
+            </a:pPr>
+            <a:r>
+              <a:rPr lang="en-US" sz="1100" b="1" dirty="0">
+                <a:solidFill>
+                  <a:srgbClr val="3B82F6"/>
+                </a:solidFill>
+                <a:latin typeface="Calibri" pitchFamily="34" charset="0"/>
+                <a:ea typeface="Calibri" pitchFamily="34" charset="-122"/>
+                <a:cs typeface="Calibri" pitchFamily="34" charset="-120"/>
+              </a:rPr>
+              <a:t>05</a:t>
+            </a:r>
+            <a:endParaRPr lang="en-US" sz="1100" dirty="0"/>
+          </a:p>
+        </p:txBody>
+      </p:sp>
+      <p:sp>
+        <p:nvSpPr>
+          <p:cNvPr id="40" name="Text 38">
+            <a:extLst>
+              <a:ext uri="{FF2B5EF4-FFF2-40B4-BE49-F238E27FC236}">
+                <a16:creationId xmlns:a16="http://schemas.microsoft.com/office/drawing/2014/main" id="{AE396FAD-4282-2904-7F24-3BC46B3C81B3}"/>
+              </a:ext>
+            </a:extLst>
+          </p:cNvPr>
+          <p:cNvSpPr/>
+          <p:nvPr/>
+        </p:nvSpPr>
+        <p:spPr>
+          <a:xfrm>
+            <a:off x="8430760" y="3110865"/>
+            <a:ext cx="1417320" cy="457200"/>
+          </a:xfrm>
+          <a:prstGeom prst="rect">
+            <a:avLst/>
+          </a:prstGeom>
+          <a:noFill/>
+          <a:ln/>
+        </p:spPr>
+        <p:txBody>
+          <a:bodyPr wrap="square" rtlCol="0" anchor="ctr"/>
+          <a:lstStyle/>
+          <a:p>
+            <a:pPr marL="0" indent="0" algn="ctr">
+              <a:buNone/>
+            </a:pPr>
+            <a:r>
+              <a:rPr lang="en-US" sz="1200" b="1" dirty="0">
+                <a:solidFill>
+                  <a:srgbClr val="0F172A"/>
+                </a:solidFill>
+                <a:latin typeface="Calibri" pitchFamily="34" charset="0"/>
+                <a:ea typeface="Calibri" pitchFamily="34" charset="-122"/>
+                <a:cs typeface="Calibri" pitchFamily="34" charset="-120"/>
+              </a:rPr>
+              <a:t>Full-Stack Link</a:t>
+            </a:r>
+            <a:endParaRPr lang="en-US" sz="1200" dirty="0"/>
+          </a:p>
+        </p:txBody>
+      </p:sp>
+      <p:sp>
+        <p:nvSpPr>
+          <p:cNvPr id="41" name="Text 39">
+            <a:extLst>
+              <a:ext uri="{FF2B5EF4-FFF2-40B4-BE49-F238E27FC236}">
+                <a16:creationId xmlns:a16="http://schemas.microsoft.com/office/drawing/2014/main" id="{90297016-70C6-F239-93C3-EF84DFDA627C}"/>
+              </a:ext>
+            </a:extLst>
+          </p:cNvPr>
+          <p:cNvSpPr/>
+          <p:nvPr/>
+        </p:nvSpPr>
+        <p:spPr>
+          <a:xfrm>
+            <a:off x="8430760" y="3659505"/>
+            <a:ext cx="1417320" cy="1481328"/>
+          </a:xfrm>
+          <a:prstGeom prst="rect">
+            <a:avLst/>
+          </a:prstGeom>
+          <a:noFill/>
+          <a:ln/>
+        </p:spPr>
+        <p:txBody>
+          <a:bodyPr wrap="square" rtlCol="0" anchor="ctr"/>
+          <a:lstStyle/>
+          <a:p>
+            <a:pPr marL="0" indent="0" algn="ctr">
+              <a:buNone/>
+            </a:pPr>
+            <a:r>
+              <a:rPr lang="en-US" sz="1000" dirty="0">
+                <a:solidFill>
+                  <a:srgbClr val="475569"/>
+                </a:solidFill>
+                <a:latin typeface="Calibri" pitchFamily="34" charset="0"/>
+                <a:ea typeface="Calibri" pitchFamily="34" charset="-122"/>
+                <a:cs typeface="Calibri" pitchFamily="34" charset="-120"/>
+              </a:rPr>
+              <a:t>Type-safe React frontend data wiring</a:t>
+            </a:r>
+            <a:endParaRPr lang="en-US" sz="1000" dirty="0"/>
+          </a:p>
+        </p:txBody>
+      </p:sp>
+      <p:sp>
+        <p:nvSpPr>
+          <p:cNvPr id="42" name="Text 40">
+            <a:extLst>
+              <a:ext uri="{FF2B5EF4-FFF2-40B4-BE49-F238E27FC236}">
+                <a16:creationId xmlns:a16="http://schemas.microsoft.com/office/drawing/2014/main" id="{4D935AED-C9FA-910C-D6C5-E14C0C77C958}"/>
+              </a:ext>
+            </a:extLst>
+          </p:cNvPr>
+          <p:cNvSpPr/>
+          <p:nvPr/>
+        </p:nvSpPr>
+        <p:spPr>
+          <a:xfrm>
+            <a:off x="3054088" y="3312033"/>
+            <a:ext cx="73152" cy="256032"/>
+          </a:xfrm>
+          <a:prstGeom prst="rect">
+            <a:avLst/>
+          </a:prstGeom>
+          <a:noFill/>
+          <a:ln/>
+        </p:spPr>
+        <p:txBody>
+          <a:bodyPr wrap="square" rtlCol="0" anchor="ctr"/>
+          <a:lstStyle/>
+          <a:p>
+            <a:pPr marL="0" indent="0" algn="ctr">
+              <a:buNone/>
+            </a:pPr>
+            <a:r>
+              <a:rPr lang="en-US" sz="1400" dirty="0">
+                <a:solidFill>
+                  <a:srgbClr val="94A3B8"/>
+                </a:solidFill>
+                <a:latin typeface="Calibri" pitchFamily="34" charset="0"/>
+                <a:ea typeface="Calibri" pitchFamily="34" charset="-122"/>
+                <a:cs typeface="Calibri" pitchFamily="34" charset="-120"/>
+              </a:rPr>
+              <a:t>→</a:t>
+            </a:r>
+            <a:endParaRPr lang="en-US" sz="1400" dirty="0"/>
+          </a:p>
+        </p:txBody>
+      </p:sp>
+      <p:sp>
+        <p:nvSpPr>
+          <p:cNvPr id="43" name="Text 41">
+            <a:extLst>
+              <a:ext uri="{FF2B5EF4-FFF2-40B4-BE49-F238E27FC236}">
+                <a16:creationId xmlns:a16="http://schemas.microsoft.com/office/drawing/2014/main" id="{98E72CC9-77F2-44F7-450E-2066EDA55298}"/>
+              </a:ext>
+            </a:extLst>
+          </p:cNvPr>
+          <p:cNvSpPr/>
+          <p:nvPr/>
+        </p:nvSpPr>
+        <p:spPr>
+          <a:xfrm>
+            <a:off x="4791448" y="3312033"/>
+            <a:ext cx="73152" cy="256032"/>
+          </a:xfrm>
+          <a:prstGeom prst="rect">
+            <a:avLst/>
+          </a:prstGeom>
+          <a:noFill/>
+          <a:ln/>
+        </p:spPr>
+        <p:txBody>
+          <a:bodyPr wrap="square" rtlCol="0" anchor="ctr"/>
+          <a:lstStyle/>
+          <a:p>
+            <a:pPr marL="0" indent="0" algn="ctr">
+              <a:buNone/>
+            </a:pPr>
+            <a:r>
+              <a:rPr lang="en-US" sz="1400" dirty="0">
+                <a:solidFill>
+                  <a:srgbClr val="94A3B8"/>
+                </a:solidFill>
+                <a:latin typeface="Calibri" pitchFamily="34" charset="0"/>
+                <a:ea typeface="Calibri" pitchFamily="34" charset="-122"/>
+                <a:cs typeface="Calibri" pitchFamily="34" charset="-120"/>
+              </a:rPr>
+              <a:t>→</a:t>
+            </a:r>
+            <a:endParaRPr lang="en-US" sz="1400" dirty="0"/>
+          </a:p>
+        </p:txBody>
+      </p:sp>
+      <p:sp>
+        <p:nvSpPr>
+          <p:cNvPr id="44" name="Text 42">
+            <a:extLst>
+              <a:ext uri="{FF2B5EF4-FFF2-40B4-BE49-F238E27FC236}">
+                <a16:creationId xmlns:a16="http://schemas.microsoft.com/office/drawing/2014/main" id="{3E62329F-D397-F1A4-53F8-B7EAF3EA4F69}"/>
+              </a:ext>
+            </a:extLst>
+          </p:cNvPr>
+          <p:cNvSpPr/>
+          <p:nvPr/>
+        </p:nvSpPr>
+        <p:spPr>
+          <a:xfrm>
+            <a:off x="6528808" y="3312033"/>
+            <a:ext cx="73152" cy="256032"/>
+          </a:xfrm>
+          <a:prstGeom prst="rect">
+            <a:avLst/>
+          </a:prstGeom>
+          <a:noFill/>
+          <a:ln/>
+        </p:spPr>
+        <p:txBody>
+          <a:bodyPr wrap="square" rtlCol="0" anchor="ctr"/>
+          <a:lstStyle/>
+          <a:p>
+            <a:pPr marL="0" indent="0" algn="ctr">
+              <a:buNone/>
+            </a:pPr>
+            <a:r>
+              <a:rPr lang="en-US" sz="1400" dirty="0">
+                <a:solidFill>
+                  <a:srgbClr val="94A3B8"/>
+                </a:solidFill>
+                <a:latin typeface="Calibri" pitchFamily="34" charset="0"/>
+                <a:ea typeface="Calibri" pitchFamily="34" charset="-122"/>
+                <a:cs typeface="Calibri" pitchFamily="34" charset="-120"/>
+              </a:rPr>
+              <a:t>→</a:t>
+            </a:r>
+            <a:endParaRPr lang="en-US" sz="1400" dirty="0"/>
+          </a:p>
+        </p:txBody>
+      </p:sp>
+      <p:sp>
+        <p:nvSpPr>
+          <p:cNvPr id="45" name="Text 43">
+            <a:extLst>
+              <a:ext uri="{FF2B5EF4-FFF2-40B4-BE49-F238E27FC236}">
+                <a16:creationId xmlns:a16="http://schemas.microsoft.com/office/drawing/2014/main" id="{5343330D-E2C6-70A8-C38E-20E2B273AEEC}"/>
+              </a:ext>
+            </a:extLst>
+          </p:cNvPr>
+          <p:cNvSpPr/>
+          <p:nvPr/>
+        </p:nvSpPr>
+        <p:spPr>
+          <a:xfrm>
+            <a:off x="8266168" y="3312033"/>
+            <a:ext cx="73152" cy="256032"/>
+          </a:xfrm>
+          <a:prstGeom prst="rect">
+            <a:avLst/>
+          </a:prstGeom>
+          <a:noFill/>
+          <a:ln/>
+        </p:spPr>
+        <p:txBody>
+          <a:bodyPr wrap="square" rtlCol="0" anchor="ctr"/>
+          <a:lstStyle/>
+          <a:p>
+            <a:pPr marL="0" indent="0" algn="ctr">
+              <a:buNone/>
+            </a:pPr>
+            <a:r>
+              <a:rPr lang="en-US" sz="1400" dirty="0">
+                <a:solidFill>
+                  <a:srgbClr val="94A3B8"/>
+                </a:solidFill>
+                <a:latin typeface="Calibri" pitchFamily="34" charset="0"/>
+                <a:ea typeface="Calibri" pitchFamily="34" charset="-122"/>
+                <a:cs typeface="Calibri" pitchFamily="34" charset="-120"/>
+              </a:rPr>
+              <a:t>→</a:t>
+            </a:r>
+            <a:endParaRPr lang="en-US" sz="1400" dirty="0"/>
+          </a:p>
+        </p:txBody>
+      </p:sp>
     </p:spTree>
   </p:cSld>
   <p:clrMapOvr>
@@ -12524,17 +13553,15 @@
 <file path=ppt/slides/slide3.xml><?xml version="1.0" encoding="utf-8"?>
 <p:sld xmlns:a="http://schemas.openxmlformats.org/drawingml/2006/main" xmlns:r="http://schemas.openxmlformats.org/officeDocument/2006/relationships" xmlns:p="http://schemas.openxmlformats.org/presentationml/2006/main">
   <p:cSld>
-    <p:bg>
-      <p:bgPr>
-        <a:solidFill>
-          <a:srgbClr val="FFFFFF"/>
-        </a:solidFill>
-        <a:effectLst/>
-      </p:bgPr>
-    </p:bg>
     <p:spTree>
       <p:nvGrpSpPr>
-        <p:cNvPr id="1" name="Shape 110"/>
+        <p:cNvPr id="1" name="Shape 110">
+          <a:extLst>
+            <a:ext uri="{FF2B5EF4-FFF2-40B4-BE49-F238E27FC236}">
+              <a16:creationId xmlns:a16="http://schemas.microsoft.com/office/drawing/2014/main" id="{3F1089AF-E4DA-2DA3-28C7-620B51CD2334}"/>
+            </a:ext>
+          </a:extLst>
+        </p:cNvPr>
         <p:cNvGrpSpPr/>
         <p:nvPr/>
       </p:nvGrpSpPr>
@@ -12548,7 +13575,13 @@
       </p:grpSpPr>
       <p:pic>
         <p:nvPicPr>
-          <p:cNvPr id="111" name="Google Shape;111;p15" descr="image.png"/>
+          <p:cNvPr id="111" name="Google Shape;111;p15" descr="image.png">
+            <a:extLst>
+              <a:ext uri="{FF2B5EF4-FFF2-40B4-BE49-F238E27FC236}">
+                <a16:creationId xmlns:a16="http://schemas.microsoft.com/office/drawing/2014/main" id="{289FE359-4B17-C918-1C97-16E1E9DCACFD}"/>
+              </a:ext>
+            </a:extLst>
+          </p:cNvPr>
           <p:cNvPicPr preferRelativeResize="0"/>
           <p:nvPr/>
         </p:nvPicPr>
@@ -12575,7 +13608,13 @@
       </p:pic>
       <p:pic>
         <p:nvPicPr>
-          <p:cNvPr id="112" name="Google Shape;112;p15" descr="image.png"/>
+          <p:cNvPr id="112" name="Google Shape;112;p15" descr="image.png">
+            <a:extLst>
+              <a:ext uri="{FF2B5EF4-FFF2-40B4-BE49-F238E27FC236}">
+                <a16:creationId xmlns:a16="http://schemas.microsoft.com/office/drawing/2014/main" id="{0CB200DE-15C8-93B7-A3CD-2150F7080C49}"/>
+              </a:ext>
+            </a:extLst>
+          </p:cNvPr>
           <p:cNvPicPr preferRelativeResize="0"/>
           <p:nvPr/>
         </p:nvPicPr>
@@ -12602,7 +13641,13 @@
       </p:pic>
       <p:pic>
         <p:nvPicPr>
-          <p:cNvPr id="113" name="Google Shape;113;p15" descr="image.png"/>
+          <p:cNvPr id="113" name="Google Shape;113;p15" descr="image.png">
+            <a:extLst>
+              <a:ext uri="{FF2B5EF4-FFF2-40B4-BE49-F238E27FC236}">
+                <a16:creationId xmlns:a16="http://schemas.microsoft.com/office/drawing/2014/main" id="{5A1BD5DA-4568-FE4C-5420-FB232730C629}"/>
+              </a:ext>
+            </a:extLst>
+          </p:cNvPr>
           <p:cNvPicPr preferRelativeResize="0"/>
           <p:nvPr/>
         </p:nvPicPr>
@@ -12629,7 +13674,13 @@
       </p:pic>
       <p:pic>
         <p:nvPicPr>
-          <p:cNvPr id="114" name="Google Shape;114;p15" descr="image.png"/>
+          <p:cNvPr id="114" name="Google Shape;114;p15" descr="image.png">
+            <a:extLst>
+              <a:ext uri="{FF2B5EF4-FFF2-40B4-BE49-F238E27FC236}">
+                <a16:creationId xmlns:a16="http://schemas.microsoft.com/office/drawing/2014/main" id="{AEB5464D-57F1-0377-A4EF-183CB6BA307A}"/>
+              </a:ext>
+            </a:extLst>
+          </p:cNvPr>
           <p:cNvPicPr preferRelativeResize="0"/>
           <p:nvPr/>
         </p:nvPicPr>
@@ -12656,7 +13707,13 @@
       </p:pic>
       <p:pic>
         <p:nvPicPr>
-          <p:cNvPr id="115" name="Google Shape;115;p15" descr="image.png"/>
+          <p:cNvPr id="115" name="Google Shape;115;p15" descr="image.png">
+            <a:extLst>
+              <a:ext uri="{FF2B5EF4-FFF2-40B4-BE49-F238E27FC236}">
+                <a16:creationId xmlns:a16="http://schemas.microsoft.com/office/drawing/2014/main" id="{5DCD95B0-2724-EF58-9C13-E12931910688}"/>
+              </a:ext>
+            </a:extLst>
+          </p:cNvPr>
           <p:cNvPicPr preferRelativeResize="0"/>
           <p:nvPr/>
         </p:nvPicPr>
@@ -12683,7 +13740,13 @@
       </p:pic>
       <p:pic>
         <p:nvPicPr>
-          <p:cNvPr id="116" name="Google Shape;116;p15" descr="image.png"/>
+          <p:cNvPr id="116" name="Google Shape;116;p15" descr="image.png">
+            <a:extLst>
+              <a:ext uri="{FF2B5EF4-FFF2-40B4-BE49-F238E27FC236}">
+                <a16:creationId xmlns:a16="http://schemas.microsoft.com/office/drawing/2014/main" id="{6B2677E1-DA80-0999-3D56-714AB117E61B}"/>
+              </a:ext>
+            </a:extLst>
+          </p:cNvPr>
           <p:cNvPicPr preferRelativeResize="0"/>
           <p:nvPr/>
         </p:nvPicPr>
@@ -12710,7 +13773,13 @@
       </p:pic>
       <p:sp>
         <p:nvSpPr>
-          <p:cNvPr id="117" name="Google Shape;117;p15"/>
+          <p:cNvPr id="117" name="Google Shape;117;p15">
+            <a:extLst>
+              <a:ext uri="{FF2B5EF4-FFF2-40B4-BE49-F238E27FC236}">
+                <a16:creationId xmlns:a16="http://schemas.microsoft.com/office/drawing/2014/main" id="{507E8E6B-A56A-A6C6-8781-DC415B1CB072}"/>
+              </a:ext>
+            </a:extLst>
+          </p:cNvPr>
           <p:cNvSpPr txBox="1"/>
           <p:nvPr/>
         </p:nvSpPr>
@@ -12760,7 +13829,13 @@
       </p:sp>
       <p:sp>
         <p:nvSpPr>
-          <p:cNvPr id="118" name="Google Shape;118;p15"/>
+          <p:cNvPr id="118" name="Google Shape;118;p15">
+            <a:extLst>
+              <a:ext uri="{FF2B5EF4-FFF2-40B4-BE49-F238E27FC236}">
+                <a16:creationId xmlns:a16="http://schemas.microsoft.com/office/drawing/2014/main" id="{0572F5F3-DF25-7626-6A3E-437F864178FD}"/>
+              </a:ext>
+            </a:extLst>
+          </p:cNvPr>
           <p:cNvSpPr txBox="1"/>
           <p:nvPr/>
         </p:nvSpPr>
@@ -12813,7 +13888,13 @@
       </p:sp>
       <p:sp>
         <p:nvSpPr>
-          <p:cNvPr id="119" name="Google Shape;119;p15"/>
+          <p:cNvPr id="119" name="Google Shape;119;p15">
+            <a:extLst>
+              <a:ext uri="{FF2B5EF4-FFF2-40B4-BE49-F238E27FC236}">
+                <a16:creationId xmlns:a16="http://schemas.microsoft.com/office/drawing/2014/main" id="{AFD215E5-4FF4-84D3-09F2-5C33F6B6800D}"/>
+              </a:ext>
+            </a:extLst>
+          </p:cNvPr>
           <p:cNvSpPr txBox="1"/>
           <p:nvPr/>
         </p:nvSpPr>
@@ -12863,7 +13944,13 @@
       </p:sp>
       <p:sp>
         <p:nvSpPr>
-          <p:cNvPr id="120" name="Google Shape;120;p15"/>
+          <p:cNvPr id="120" name="Google Shape;120;p15">
+            <a:extLst>
+              <a:ext uri="{FF2B5EF4-FFF2-40B4-BE49-F238E27FC236}">
+                <a16:creationId xmlns:a16="http://schemas.microsoft.com/office/drawing/2014/main" id="{DF33BDD6-A637-5DCA-BFFC-A92BB138C2EF}"/>
+              </a:ext>
+            </a:extLst>
+          </p:cNvPr>
           <p:cNvSpPr txBox="1"/>
           <p:nvPr/>
         </p:nvSpPr>
@@ -12916,7 +14003,13 @@
       </p:sp>
       <p:sp>
         <p:nvSpPr>
-          <p:cNvPr id="121" name="Google Shape;121;p15"/>
+          <p:cNvPr id="121" name="Google Shape;121;p15">
+            <a:extLst>
+              <a:ext uri="{FF2B5EF4-FFF2-40B4-BE49-F238E27FC236}">
+                <a16:creationId xmlns:a16="http://schemas.microsoft.com/office/drawing/2014/main" id="{7EC840EC-014B-5E02-6786-C247E7B54FA9}"/>
+              </a:ext>
+            </a:extLst>
+          </p:cNvPr>
           <p:cNvSpPr txBox="1"/>
           <p:nvPr/>
         </p:nvSpPr>
@@ -12966,7 +14059,13 @@
       </p:sp>
       <p:sp>
         <p:nvSpPr>
-          <p:cNvPr id="122" name="Google Shape;122;p15"/>
+          <p:cNvPr id="122" name="Google Shape;122;p15">
+            <a:extLst>
+              <a:ext uri="{FF2B5EF4-FFF2-40B4-BE49-F238E27FC236}">
+                <a16:creationId xmlns:a16="http://schemas.microsoft.com/office/drawing/2014/main" id="{03BBC31F-459D-6CB6-DF5B-C232ABD5E0E9}"/>
+              </a:ext>
+            </a:extLst>
+          </p:cNvPr>
           <p:cNvSpPr txBox="1"/>
           <p:nvPr/>
         </p:nvSpPr>
@@ -13019,7 +14118,13 @@
       </p:sp>
       <p:sp>
         <p:nvSpPr>
-          <p:cNvPr id="123" name="Google Shape;123;p15"/>
+          <p:cNvPr id="123" name="Google Shape;123;p15">
+            <a:extLst>
+              <a:ext uri="{FF2B5EF4-FFF2-40B4-BE49-F238E27FC236}">
+                <a16:creationId xmlns:a16="http://schemas.microsoft.com/office/drawing/2014/main" id="{899E71A9-661D-3A6A-62A5-A94D42CB6801}"/>
+              </a:ext>
+            </a:extLst>
+          </p:cNvPr>
           <p:cNvSpPr txBox="1"/>
           <p:nvPr/>
         </p:nvSpPr>
@@ -13069,7 +14174,13 @@
       </p:sp>
       <p:sp>
         <p:nvSpPr>
-          <p:cNvPr id="124" name="Google Shape;124;p15"/>
+          <p:cNvPr id="124" name="Google Shape;124;p15">
+            <a:extLst>
+              <a:ext uri="{FF2B5EF4-FFF2-40B4-BE49-F238E27FC236}">
+                <a16:creationId xmlns:a16="http://schemas.microsoft.com/office/drawing/2014/main" id="{1351EBAE-0EC8-BF2D-852F-F00D2A7CBA90}"/>
+              </a:ext>
+            </a:extLst>
+          </p:cNvPr>
           <p:cNvSpPr txBox="1"/>
           <p:nvPr/>
         </p:nvSpPr>
@@ -13122,7 +14233,13 @@
       </p:sp>
       <p:sp>
         <p:nvSpPr>
-          <p:cNvPr id="125" name="Google Shape;125;p15"/>
+          <p:cNvPr id="125" name="Google Shape;125;p15">
+            <a:extLst>
+              <a:ext uri="{FF2B5EF4-FFF2-40B4-BE49-F238E27FC236}">
+                <a16:creationId xmlns:a16="http://schemas.microsoft.com/office/drawing/2014/main" id="{684B174E-3412-338F-A603-085974F2D048}"/>
+              </a:ext>
+            </a:extLst>
+          </p:cNvPr>
           <p:cNvSpPr txBox="1"/>
           <p:nvPr/>
         </p:nvSpPr>
@@ -13172,7 +14289,13 @@
       </p:sp>
       <p:sp>
         <p:nvSpPr>
-          <p:cNvPr id="126" name="Google Shape;126;p15"/>
+          <p:cNvPr id="126" name="Google Shape;126;p15">
+            <a:extLst>
+              <a:ext uri="{FF2B5EF4-FFF2-40B4-BE49-F238E27FC236}">
+                <a16:creationId xmlns:a16="http://schemas.microsoft.com/office/drawing/2014/main" id="{65DFB289-2342-0D2E-AC82-AF599226176E}"/>
+              </a:ext>
+            </a:extLst>
+          </p:cNvPr>
           <p:cNvSpPr txBox="1"/>
           <p:nvPr/>
         </p:nvSpPr>
@@ -13225,7 +14348,13 @@
       </p:sp>
       <p:sp>
         <p:nvSpPr>
-          <p:cNvPr id="127" name="Google Shape;127;p15"/>
+          <p:cNvPr id="127" name="Google Shape;127;p15">
+            <a:extLst>
+              <a:ext uri="{FF2B5EF4-FFF2-40B4-BE49-F238E27FC236}">
+                <a16:creationId xmlns:a16="http://schemas.microsoft.com/office/drawing/2014/main" id="{39D375E1-3EFC-7414-F538-1D94922B22EB}"/>
+              </a:ext>
+            </a:extLst>
+          </p:cNvPr>
           <p:cNvSpPr txBox="1"/>
           <p:nvPr/>
         </p:nvSpPr>
@@ -13275,7 +14404,13 @@
       </p:sp>
       <p:sp>
         <p:nvSpPr>
-          <p:cNvPr id="128" name="Google Shape;128;p15"/>
+          <p:cNvPr id="128" name="Google Shape;128;p15">
+            <a:extLst>
+              <a:ext uri="{FF2B5EF4-FFF2-40B4-BE49-F238E27FC236}">
+                <a16:creationId xmlns:a16="http://schemas.microsoft.com/office/drawing/2014/main" id="{5DB729AD-9346-20F3-386F-6765708A4CB7}"/>
+              </a:ext>
+            </a:extLst>
+          </p:cNvPr>
           <p:cNvSpPr/>
           <p:nvPr/>
         </p:nvSpPr>
@@ -13322,6 +14457,11 @@
         </p:txBody>
       </p:sp>
     </p:spTree>
+    <p:extLst>
+      <p:ext uri="{BB962C8B-B14F-4D97-AF65-F5344CB8AC3E}">
+        <p14:creationId xmlns:p14="http://schemas.microsoft.com/office/powerpoint/2010/main" val="2037579618"/>
+      </p:ext>
+    </p:extLst>
   </p:cSld>
   <p:clrMapOvr>
     <a:masterClrMapping/>
@@ -13381,23 +14521,16 @@
           </a:ln>
         </p:spPr>
       </p:pic>
-      <p:pic>
-        <p:nvPicPr>
-          <p:cNvPr id="134" name="Google Shape;134;p16" descr="image.png"/>
-          <p:cNvPicPr preferRelativeResize="0"/>
+      <p:sp>
+        <p:nvSpPr>
+          <p:cNvPr id="136" name="Google Shape;136;p16"/>
+          <p:cNvSpPr txBox="1"/>
           <p:nvPr/>
-        </p:nvPicPr>
-        <p:blipFill rotWithShape="1">
-          <a:blip r:embed="rId4">
-            <a:alphaModFix/>
-          </a:blip>
-          <a:srcRect/>
-          <a:stretch/>
-        </p:blipFill>
-        <p:spPr>
-          <a:xfrm>
-            <a:off x="666750" y="1900237"/>
-            <a:ext cx="6229350" cy="4000500"/>
+        </p:nvSpPr>
+        <p:spPr>
+          <a:xfrm>
+            <a:off x="7156223" y="1976612"/>
+            <a:ext cx="4360545" cy="276225"/>
           </a:xfrm>
           <a:prstGeom prst="rect">
             <a:avLst/>
@@ -13407,53 +14540,6 @@
             <a:noFill/>
           </a:ln>
         </p:spPr>
-      </p:pic>
-      <p:pic>
-        <p:nvPicPr>
-          <p:cNvPr id="135" name="Google Shape;135;p16" descr="image.png"/>
-          <p:cNvPicPr preferRelativeResize="0"/>
-          <p:nvPr/>
-        </p:nvPicPr>
-        <p:blipFill rotWithShape="1">
-          <a:blip r:embed="rId5">
-            <a:alphaModFix/>
-          </a:blip>
-          <a:srcRect/>
-          <a:stretch/>
-        </p:blipFill>
-        <p:spPr>
-          <a:xfrm>
-            <a:off x="676275" y="1909762"/>
-            <a:ext cx="1828800" cy="190500"/>
-          </a:xfrm>
-          <a:prstGeom prst="rect">
-            <a:avLst/>
-          </a:prstGeom>
-          <a:noFill/>
-          <a:ln>
-            <a:noFill/>
-          </a:ln>
-        </p:spPr>
-      </p:pic>
-      <p:sp>
-        <p:nvSpPr>
-          <p:cNvPr id="136" name="Google Shape;136;p16"/>
-          <p:cNvSpPr txBox="1"/>
-          <p:nvPr/>
-        </p:nvSpPr>
-        <p:spPr>
-          <a:xfrm>
-            <a:off x="7372350" y="2043112"/>
-            <a:ext cx="4360545" cy="276225"/>
-          </a:xfrm>
-          <a:prstGeom prst="rect">
-            <a:avLst/>
-          </a:prstGeom>
-          <a:noFill/>
-          <a:ln>
-            <a:noFill/>
-          </a:ln>
-        </p:spPr>
         <p:txBody>
           <a:bodyPr spcFirstLastPara="1" wrap="square" lIns="0" tIns="0" rIns="0" bIns="0" anchor="t" anchorCtr="0">
             <a:spAutoFit/>
@@ -13470,7 +14556,7 @@
               <a:buNone/>
             </a:pPr>
             <a:r>
-              <a:rPr lang="en-US" sz="1404" b="1" i="0" u="none" strike="noStrike" cap="none">
+              <a:rPr lang="en-US" sz="1404" b="1" i="0" u="none" strike="noStrike" cap="none" dirty="0">
                 <a:solidFill>
                   <a:srgbClr val="10B981"/>
                 </a:solidFill>
@@ -13481,7 +14567,7 @@
               </a:rPr>
               <a:t>Normalization &amp; Performance</a:t>
             </a:r>
-            <a:endParaRPr/>
+            <a:endParaRPr dirty="0"/>
           </a:p>
         </p:txBody>
       </p:sp>
@@ -13493,7 +14579,7 @@
         </p:nvSpPr>
         <p:spPr>
           <a:xfrm>
-            <a:off x="7372350" y="2500312"/>
+            <a:off x="7156223" y="2433812"/>
             <a:ext cx="4152900" cy="1085850"/>
           </a:xfrm>
           <a:prstGeom prst="rect">
@@ -13523,7 +14609,7 @@
               <a:buNone/>
             </a:pPr>
             <a:r>
-              <a:rPr lang="en-US" sz="1425" b="0" i="0" u="none" strike="noStrike" cap="none">
+              <a:rPr lang="en-US" sz="1425" b="0" i="0" u="none" strike="noStrike" cap="none" dirty="0">
                 <a:solidFill>
                   <a:srgbClr val="0F172A"/>
                 </a:solidFill>
@@ -13535,7 +14621,7 @@
               <a:t>3NF Compliance:</a:t>
             </a:r>
             <a:r>
-              <a:rPr lang="en-US" sz="1425" b="0" i="0" u="none" strike="noStrike" cap="none">
+              <a:rPr lang="en-US" sz="1425" b="0" i="0" u="none" strike="noStrike" cap="none" dirty="0">
                 <a:solidFill>
                   <a:srgbClr val="334155"/>
                 </a:solidFill>
@@ -13546,7 +14632,7 @@
               </a:rPr>
               <a:t> We architected the schema following 3rd Normal Form rules to eliminate data redundancy and ensure transactional integrity.</a:t>
             </a:r>
-            <a:endParaRPr/>
+            <a:endParaRPr dirty="0"/>
           </a:p>
         </p:txBody>
       </p:sp>
@@ -13558,7 +14644,7 @@
         </p:nvSpPr>
         <p:spPr>
           <a:xfrm>
-            <a:off x="7372350" y="3767137"/>
+            <a:off x="7156223" y="3700637"/>
             <a:ext cx="4152900" cy="814387"/>
           </a:xfrm>
           <a:prstGeom prst="rect">
@@ -13623,7 +14709,7 @@
         </p:nvSpPr>
         <p:spPr>
           <a:xfrm>
-            <a:off x="7372350" y="4762500"/>
+            <a:off x="7156223" y="4696000"/>
             <a:ext cx="4152900" cy="814387"/>
           </a:xfrm>
           <a:prstGeom prst="rect">
@@ -13778,6 +14864,36 @@
           </a:p>
         </p:txBody>
       </p:sp>
+      <p:pic>
+        <p:nvPicPr>
+          <p:cNvPr id="3" name="Picture 2">
+            <a:extLst>
+              <a:ext uri="{FF2B5EF4-FFF2-40B4-BE49-F238E27FC236}">
+                <a16:creationId xmlns:a16="http://schemas.microsoft.com/office/drawing/2014/main" id="{883F80DE-3BA8-D9BF-CBF1-7FA2DA1E2C98}"/>
+              </a:ext>
+            </a:extLst>
+          </p:cNvPr>
+          <p:cNvPicPr>
+            <a:picLocks noChangeAspect="1"/>
+          </p:cNvPicPr>
+          <p:nvPr/>
+        </p:nvPicPr>
+        <p:blipFill>
+          <a:blip r:embed="rId4"/>
+          <a:stretch>
+            <a:fillRect/>
+          </a:stretch>
+        </p:blipFill>
+        <p:spPr>
+          <a:xfrm>
+            <a:off x="1354368" y="1344489"/>
+            <a:ext cx="4663614" cy="5396187"/>
+          </a:xfrm>
+          <a:prstGeom prst="rect">
+            <a:avLst/>
+          </a:prstGeom>
+        </p:spPr>
+      </p:pic>
     </p:spTree>
   </p:cSld>
   <p:clrMapOvr>
@@ -13899,7 +15015,7 @@
         </p:nvGraphicFramePr>
         <p:xfrm>
           <a:off x="666750" y="2305050"/>
-          <a:ext cx="3000000" cy="3000000"/>
+          <a:ext cx="10858500" cy="2619325"/>
         </p:xfrm>
         <a:graphic>
           <a:graphicData uri="http://schemas.openxmlformats.org/drawingml/2006/table">
@@ -15225,7 +16341,7 @@
                         <a:buNone/>
                       </a:pPr>
                       <a:r>
-                        <a:rPr lang="en-US" sz="1200" b="0" i="0" u="none" strike="noStrike" cap="none">
+                        <a:rPr lang="en-US" sz="1200" b="0" i="0" u="none" strike="noStrike" cap="none" dirty="0">
                           <a:solidFill>
                             <a:srgbClr val="000000"/>
                           </a:solidFill>
@@ -15236,7 +16352,7 @@
                         </a:rPr>
                         <a:t>1 : N</a:t>
                       </a:r>
-                      <a:endParaRPr/>
+                      <a:endParaRPr dirty="0"/>
                     </a:p>
                   </a:txBody>
                   <a:tcPr marL="63500" marR="63500" marT="25400" marB="25400" anchor="ctr">
@@ -15301,7 +16417,7 @@
                         <a:buNone/>
                       </a:pPr>
                       <a:r>
-                        <a:rPr lang="en-US" sz="1200" b="0" i="0" u="none" strike="noStrike" cap="none">
+                        <a:rPr lang="en-US" sz="1200" b="0" i="0" u="none" strike="noStrike" cap="none" dirty="0">
                           <a:solidFill>
                             <a:srgbClr val="000000"/>
                           </a:solidFill>
@@ -15312,7 +16428,7 @@
                         </a:rPr>
                         <a:t>Data artifacts processed by recommendation engines.</a:t>
                       </a:r>
-                      <a:endParaRPr/>
+                      <a:endParaRPr dirty="0"/>
                     </a:p>
                   </a:txBody>
                   <a:tcPr marL="63500" marR="63500" marT="25400" marB="25400" anchor="ctr">
@@ -16497,29 +17613,32 @@
       </p:sp>
       <p:pic>
         <p:nvPicPr>
-          <p:cNvPr id="175" name="Google Shape;175;p18" descr="image.png"/>
-          <p:cNvPicPr preferRelativeResize="0"/>
+          <p:cNvPr id="3" name="Picture 2">
+            <a:extLst>
+              <a:ext uri="{FF2B5EF4-FFF2-40B4-BE49-F238E27FC236}">
+                <a16:creationId xmlns:a16="http://schemas.microsoft.com/office/drawing/2014/main" id="{86178F13-0520-D917-4A8C-482A8A5A264D}"/>
+              </a:ext>
+            </a:extLst>
+          </p:cNvPr>
+          <p:cNvPicPr>
+            <a:picLocks noChangeAspect="1"/>
+          </p:cNvPicPr>
           <p:nvPr/>
         </p:nvPicPr>
-        <p:blipFill rotWithShape="1">
-          <a:blip r:embed="rId4">
-            <a:alphaModFix/>
-          </a:blip>
-          <a:srcRect/>
-          <a:stretch/>
+        <p:blipFill>
+          <a:blip r:embed="rId4"/>
+          <a:stretch>
+            <a:fillRect/>
+          </a:stretch>
         </p:blipFill>
         <p:spPr>
           <a:xfrm>
-            <a:off x="6096000" y="0"/>
-            <a:ext cx="6096000" cy="6858000"/>
+            <a:off x="6343649" y="21648"/>
+            <a:ext cx="4953000" cy="6858001"/>
           </a:xfrm>
           <a:prstGeom prst="rect">
             <a:avLst/>
           </a:prstGeom>
-          <a:noFill/>
-          <a:ln>
-            <a:noFill/>
-          </a:ln>
         </p:spPr>
       </p:pic>
     </p:spTree>
@@ -17012,60 +18131,6 @@
           <a:chExt cx="0" cy="0"/>
         </a:xfrm>
       </p:grpSpPr>
-      <p:pic>
-        <p:nvPicPr>
-          <p:cNvPr id="194" name="Google Shape;194;p20" descr="image.png"/>
-          <p:cNvPicPr preferRelativeResize="0"/>
-          <p:nvPr/>
-        </p:nvPicPr>
-        <p:blipFill rotWithShape="1">
-          <a:blip r:embed="rId3">
-            <a:alphaModFix/>
-          </a:blip>
-          <a:srcRect/>
-          <a:stretch/>
-        </p:blipFill>
-        <p:spPr>
-          <a:xfrm>
-            <a:off x="666750" y="1900237"/>
-            <a:ext cx="6229350" cy="4000500"/>
-          </a:xfrm>
-          <a:prstGeom prst="rect">
-            <a:avLst/>
-          </a:prstGeom>
-          <a:noFill/>
-          <a:ln>
-            <a:noFill/>
-          </a:ln>
-        </p:spPr>
-      </p:pic>
-      <p:pic>
-        <p:nvPicPr>
-          <p:cNvPr id="195" name="Google Shape;195;p20" descr="image.png"/>
-          <p:cNvPicPr preferRelativeResize="0"/>
-          <p:nvPr/>
-        </p:nvPicPr>
-        <p:blipFill rotWithShape="1">
-          <a:blip r:embed="rId4">
-            <a:alphaModFix/>
-          </a:blip>
-          <a:srcRect/>
-          <a:stretch/>
-        </p:blipFill>
-        <p:spPr>
-          <a:xfrm>
-            <a:off x="676275" y="1909762"/>
-            <a:ext cx="6210300" cy="3981450"/>
-          </a:xfrm>
-          <a:prstGeom prst="rect">
-            <a:avLst/>
-          </a:prstGeom>
-          <a:noFill/>
-          <a:ln>
-            <a:noFill/>
-          </a:ln>
-        </p:spPr>
-      </p:pic>
       <p:sp>
         <p:nvSpPr>
           <p:cNvPr id="196" name="Google Shape;196;p20"/>
@@ -17219,7 +18284,7 @@
               <a:buNone/>
             </a:pPr>
             <a:r>
-              <a:rPr lang="en-US" sz="1425" b="0" i="0" u="none" strike="noStrike" cap="none">
+              <a:rPr lang="en-US" sz="1425" b="0" i="0" u="none" strike="noStrike" cap="none" dirty="0">
                 <a:solidFill>
                   <a:srgbClr val="0F172A"/>
                 </a:solidFill>
@@ -17231,7 +18296,7 @@
               <a:t>Authentication Guards:</a:t>
             </a:r>
             <a:r>
-              <a:rPr lang="en-US" sz="1425" b="0" i="0" u="none" strike="noStrike" cap="none">
+              <a:rPr lang="en-US" sz="1425" b="0" i="0" u="none" strike="noStrike" cap="none" dirty="0">
                 <a:solidFill>
                   <a:srgbClr val="334155"/>
                 </a:solidFill>
@@ -17242,7 +18307,7 @@
               </a:rPr>
               <a:t> Middleware layer decrypts Bearer tokens to verify user permissions before data access.</a:t>
             </a:r>
-            <a:endParaRPr/>
+            <a:endParaRPr dirty="0"/>
           </a:p>
         </p:txBody>
       </p:sp>
@@ -17409,45 +18474,12 @@
           </a:p>
         </p:txBody>
       </p:sp>
-    </p:spTree>
-  </p:cSld>
-  <p:clrMapOvr>
-    <a:masterClrMapping/>
-  </p:clrMapOvr>
-</p:sld>
-</file>
-
-<file path=ppt/slides/slide9.xml><?xml version="1.0" encoding="utf-8"?>
-<p:sld xmlns:a="http://schemas.openxmlformats.org/drawingml/2006/main" xmlns:r="http://schemas.openxmlformats.org/officeDocument/2006/relationships" xmlns:p="http://schemas.openxmlformats.org/presentationml/2006/main">
-  <p:cSld>
-    <p:bg>
-      <p:bgPr>
-        <a:solidFill>
-          <a:srgbClr val="FFFFFF"/>
-        </a:solidFill>
-        <a:effectLst/>
-      </p:bgPr>
-    </p:bg>
-    <p:spTree>
-      <p:nvGrpSpPr>
-        <p:cNvPr id="1" name="Shape 205"/>
-        <p:cNvGrpSpPr/>
-        <p:nvPr/>
-      </p:nvGrpSpPr>
-      <p:grpSpPr>
-        <a:xfrm>
-          <a:off x="0" y="0"/>
-          <a:ext cx="0" cy="0"/>
-          <a:chOff x="0" y="0"/>
-          <a:chExt cx="0" cy="0"/>
-        </a:xfrm>
-      </p:grpSpPr>
       <p:pic>
         <p:nvPicPr>
-          <p:cNvPr id="2" name="Picture 1">
+          <p:cNvPr id="3" name="Picture 2">
             <a:extLst>
               <a:ext uri="{FF2B5EF4-FFF2-40B4-BE49-F238E27FC236}">
-                <a16:creationId xmlns:a16="http://schemas.microsoft.com/office/drawing/2014/main" id="{BE8828C6-1B42-C806-EC56-CDF0F17BA740}"/>
+                <a16:creationId xmlns:a16="http://schemas.microsoft.com/office/drawing/2014/main" id="{8498C779-145E-C2BC-AADC-CC8B761F95BC}"/>
               </a:ext>
             </a:extLst>
           </p:cNvPr>
@@ -17457,446 +18489,21 @@
           <p:nvPr/>
         </p:nvPicPr>
         <p:blipFill>
-          <a:blip r:embed="rId3">
-            <a:alphaModFix amt="7000"/>
-            <a:extLst>
-              <a:ext uri="{BEBA8EAE-BF5A-486C-A8C5-ECC9F3942E4B}">
-                <a14:imgProps xmlns:a14="http://schemas.microsoft.com/office/drawing/2010/main">
-                  <a14:imgLayer r:embed="rId4">
-                    <a14:imgEffect>
-                      <a14:saturation sat="138000"/>
-                    </a14:imgEffect>
-                  </a14:imgLayer>
-                </a14:imgProps>
-              </a:ext>
-            </a:extLst>
-          </a:blip>
+          <a:blip r:embed="rId3"/>
           <a:stretch>
             <a:fillRect/>
           </a:stretch>
         </p:blipFill>
         <p:spPr>
           <a:xfrm>
-            <a:off x="2696840" y="475110"/>
-            <a:ext cx="6798319" cy="6798319"/>
+            <a:off x="666750" y="1413281"/>
+            <a:ext cx="5403048" cy="5250635"/>
           </a:xfrm>
           <a:prstGeom prst="rect">
             <a:avLst/>
           </a:prstGeom>
         </p:spPr>
       </p:pic>
-      <p:pic>
-        <p:nvPicPr>
-          <p:cNvPr id="207" name="Google Shape;207;p21" descr="image.png"/>
-          <p:cNvPicPr preferRelativeResize="0"/>
-          <p:nvPr/>
-        </p:nvPicPr>
-        <p:blipFill rotWithShape="1">
-          <a:blip r:embed="rId5">
-            <a:alphaModFix/>
-          </a:blip>
-          <a:srcRect/>
-          <a:stretch/>
-        </p:blipFill>
-        <p:spPr>
-          <a:xfrm>
-            <a:off x="7372350" y="1900237"/>
-            <a:ext cx="4152900" cy="4000500"/>
-          </a:xfrm>
-          <a:prstGeom prst="rect">
-            <a:avLst/>
-          </a:prstGeom>
-          <a:noFill/>
-          <a:ln>
-            <a:noFill/>
-          </a:ln>
-        </p:spPr>
-      </p:pic>
-      <p:sp>
-        <p:nvSpPr>
-          <p:cNvPr id="208" name="Google Shape;208;p21"/>
-          <p:cNvSpPr txBox="1"/>
-          <p:nvPr/>
-        </p:nvSpPr>
-        <p:spPr>
-          <a:xfrm>
-            <a:off x="666750" y="2626518"/>
-            <a:ext cx="6229350" cy="542925"/>
-          </a:xfrm>
-          <a:prstGeom prst="rect">
-            <a:avLst/>
-          </a:prstGeom>
-          <a:noFill/>
-          <a:ln>
-            <a:noFill/>
-          </a:ln>
-        </p:spPr>
-        <p:txBody>
-          <a:bodyPr spcFirstLastPara="1" wrap="square" lIns="0" tIns="0" rIns="0" bIns="0" anchor="t" anchorCtr="0">
-            <a:spAutoFit/>
-          </a:bodyPr>
-          <a:lstStyle/>
-          <a:p>
-            <a:pPr marL="0" marR="0" lvl="0" indent="0" algn="l" rtl="0">
-              <a:lnSpc>
-                <a:spcPct val="149964"/>
-              </a:lnSpc>
-              <a:spcBef>
-                <a:spcPts val="0"/>
-              </a:spcBef>
-              <a:spcAft>
-                <a:spcPts val="0"/>
-              </a:spcAft>
-              <a:buNone/>
-            </a:pPr>
-            <a:r>
-              <a:rPr lang="en-US" sz="1425" b="0" i="0" u="none" strike="noStrike" cap="none" dirty="0">
-                <a:solidFill>
-                  <a:srgbClr val="0F172A"/>
-                </a:solidFill>
-                <a:latin typeface="Inter"/>
-                <a:ea typeface="Inter"/>
-                <a:cs typeface="Inter"/>
-                <a:sym typeface="Inter"/>
-              </a:rPr>
-              <a:t>Dynamic Hydration:</a:t>
-            </a:r>
-            <a:r>
-              <a:rPr lang="en-US" sz="1425" b="0" i="0" u="none" strike="noStrike" cap="none" dirty="0">
-                <a:solidFill>
-                  <a:srgbClr val="334155"/>
-                </a:solidFill>
-                <a:latin typeface="Inter"/>
-                <a:ea typeface="Inter"/>
-                <a:cs typeface="Inter"/>
-                <a:sym typeface="Inter"/>
-              </a:rPr>
-              <a:t> Connected the React Dashboard to Backend endpoints using standardized async request patterns.</a:t>
-            </a:r>
-            <a:endParaRPr dirty="0"/>
-          </a:p>
-        </p:txBody>
-      </p:sp>
-      <p:sp>
-        <p:nvSpPr>
-          <p:cNvPr id="209" name="Google Shape;209;p21"/>
-          <p:cNvSpPr txBox="1"/>
-          <p:nvPr/>
-        </p:nvSpPr>
-        <p:spPr>
-          <a:xfrm>
-            <a:off x="666750" y="3350418"/>
-            <a:ext cx="6229350" cy="542925"/>
-          </a:xfrm>
-          <a:prstGeom prst="rect">
-            <a:avLst/>
-          </a:prstGeom>
-          <a:noFill/>
-          <a:ln>
-            <a:noFill/>
-          </a:ln>
-        </p:spPr>
-        <p:txBody>
-          <a:bodyPr spcFirstLastPara="1" wrap="square" lIns="0" tIns="0" rIns="0" bIns="0" anchor="t" anchorCtr="0">
-            <a:spAutoFit/>
-          </a:bodyPr>
-          <a:lstStyle/>
-          <a:p>
-            <a:pPr marL="0" marR="0" lvl="0" indent="0" algn="l" rtl="0">
-              <a:lnSpc>
-                <a:spcPct val="149964"/>
-              </a:lnSpc>
-              <a:spcBef>
-                <a:spcPts val="0"/>
-              </a:spcBef>
-              <a:spcAft>
-                <a:spcPts val="0"/>
-              </a:spcAft>
-              <a:buNone/>
-            </a:pPr>
-            <a:r>
-              <a:rPr lang="en-US" sz="1425" b="0" i="0" u="none" strike="noStrike" cap="none">
-                <a:solidFill>
-                  <a:srgbClr val="0F172A"/>
-                </a:solidFill>
-                <a:latin typeface="Inter"/>
-                <a:ea typeface="Inter"/>
-                <a:cs typeface="Inter"/>
-                <a:sym typeface="Inter"/>
-              </a:rPr>
-              <a:t>Type-Safe Rendering:</a:t>
-            </a:r>
-            <a:r>
-              <a:rPr lang="en-US" sz="1425" b="0" i="0" u="none" strike="noStrike" cap="none">
-                <a:solidFill>
-                  <a:srgbClr val="334155"/>
-                </a:solidFill>
-                <a:latin typeface="Inter"/>
-                <a:ea typeface="Inter"/>
-                <a:cs typeface="Inter"/>
-                <a:sym typeface="Inter"/>
-              </a:rPr>
-              <a:t> The UI layer is synchronized with the DB schema, ensuring charts and tables display real-time data metrics.</a:t>
-            </a:r>
-            <a:endParaRPr/>
-          </a:p>
-        </p:txBody>
-      </p:sp>
-      <p:sp>
-        <p:nvSpPr>
-          <p:cNvPr id="211" name="Google Shape;211;p21"/>
-          <p:cNvSpPr txBox="1"/>
-          <p:nvPr/>
-        </p:nvSpPr>
-        <p:spPr>
-          <a:xfrm>
-            <a:off x="666750" y="4902993"/>
-            <a:ext cx="6229350" cy="271462"/>
-          </a:xfrm>
-          <a:prstGeom prst="rect">
-            <a:avLst/>
-          </a:prstGeom>
-          <a:noFill/>
-          <a:ln>
-            <a:noFill/>
-          </a:ln>
-        </p:spPr>
-        <p:txBody>
-          <a:bodyPr spcFirstLastPara="1" wrap="square" lIns="0" tIns="0" rIns="0" bIns="0" anchor="t" anchorCtr="0">
-            <a:spAutoFit/>
-          </a:bodyPr>
-          <a:lstStyle/>
-          <a:p>
-            <a:pPr marL="0" marR="0" lvl="0" indent="0" algn="l" rtl="0">
-              <a:lnSpc>
-                <a:spcPct val="149964"/>
-              </a:lnSpc>
-              <a:spcBef>
-                <a:spcPts val="0"/>
-              </a:spcBef>
-              <a:spcAft>
-                <a:spcPts val="0"/>
-              </a:spcAft>
-              <a:buNone/>
-            </a:pPr>
-            <a:r>
-              <a:rPr lang="en-US" sz="1425" b="1" i="0" u="none" strike="noStrike" cap="none">
-                <a:solidFill>
-                  <a:srgbClr val="10B981"/>
-                </a:solidFill>
-                <a:latin typeface="Inter"/>
-                <a:ea typeface="Inter"/>
-                <a:cs typeface="Inter"/>
-                <a:sym typeface="Inter"/>
-              </a:rPr>
-              <a:t>BrainPath</a:t>
-            </a:r>
-            <a:r>
-              <a:rPr lang="en-US" sz="1425" b="1" i="0" u="none" strike="noStrike" cap="none" dirty="0">
-                <a:solidFill>
-                  <a:srgbClr val="10B981"/>
-                </a:solidFill>
-                <a:latin typeface="Inter"/>
-                <a:ea typeface="Inter"/>
-                <a:cs typeface="Inter"/>
-                <a:sym typeface="Inter"/>
-              </a:rPr>
-              <a:t> is now a fully data-driven educational platform.</a:t>
-            </a:r>
-            <a:endParaRPr dirty="0"/>
-          </a:p>
-        </p:txBody>
-      </p:sp>
-      <p:pic>
-        <p:nvPicPr>
-          <p:cNvPr id="212" name="Google Shape;212;p21" descr="image.png"/>
-          <p:cNvPicPr preferRelativeResize="0"/>
-          <p:nvPr/>
-        </p:nvPicPr>
-        <p:blipFill rotWithShape="1">
-          <a:blip r:embed="rId6">
-            <a:alphaModFix/>
-          </a:blip>
-          <a:srcRect/>
-          <a:stretch/>
-        </p:blipFill>
-        <p:spPr>
-          <a:xfrm>
-            <a:off x="7381875" y="1909762"/>
-            <a:ext cx="4133850" cy="3981450"/>
-          </a:xfrm>
-          <a:prstGeom prst="rect">
-            <a:avLst/>
-          </a:prstGeom>
-          <a:noFill/>
-          <a:ln>
-            <a:noFill/>
-          </a:ln>
-        </p:spPr>
-      </p:pic>
-      <p:sp>
-        <p:nvSpPr>
-          <p:cNvPr id="213" name="Google Shape;213;p21"/>
-          <p:cNvSpPr txBox="1"/>
-          <p:nvPr/>
-        </p:nvSpPr>
-        <p:spPr>
-          <a:xfrm>
-            <a:off x="666750" y="476250"/>
-            <a:ext cx="11401425" cy="609600"/>
-          </a:xfrm>
-          <a:prstGeom prst="rect">
-            <a:avLst/>
-          </a:prstGeom>
-          <a:noFill/>
-          <a:ln>
-            <a:noFill/>
-          </a:ln>
-        </p:spPr>
-        <p:txBody>
-          <a:bodyPr spcFirstLastPara="1" wrap="square" lIns="0" tIns="0" rIns="0" bIns="0" anchor="t" anchorCtr="0">
-            <a:spAutoFit/>
-          </a:bodyPr>
-          <a:lstStyle/>
-          <a:p>
-            <a:pPr marL="0" marR="0" lvl="0" indent="0" algn="l" rtl="0">
-              <a:spcBef>
-                <a:spcPts val="0"/>
-              </a:spcBef>
-              <a:spcAft>
-                <a:spcPts val="0"/>
-              </a:spcAft>
-              <a:buNone/>
-            </a:pPr>
-            <a:r>
-              <a:rPr lang="en-US" sz="3000" b="1" i="0" u="none" strike="noStrike" cap="none">
-                <a:solidFill>
-                  <a:srgbClr val="0F172A"/>
-                </a:solidFill>
-                <a:latin typeface="Poppins"/>
-                <a:ea typeface="Poppins"/>
-                <a:cs typeface="Poppins"/>
-                <a:sym typeface="Poppins"/>
-              </a:rPr>
-              <a:t>6. FULL-STACK INTEGRATION</a:t>
-            </a:r>
-            <a:endParaRPr/>
-          </a:p>
-        </p:txBody>
-      </p:sp>
-      <p:sp>
-        <p:nvSpPr>
-          <p:cNvPr id="214" name="Google Shape;214;p21"/>
-          <p:cNvSpPr/>
-          <p:nvPr/>
-        </p:nvSpPr>
-        <p:spPr>
-          <a:xfrm>
-            <a:off x="666750" y="1095375"/>
-            <a:ext cx="10858500" cy="38100"/>
-          </a:xfrm>
-          <a:prstGeom prst="rect">
-            <a:avLst/>
-          </a:prstGeom>
-          <a:solidFill>
-            <a:srgbClr val="10B981"/>
-          </a:solidFill>
-          <a:ln>
-            <a:noFill/>
-          </a:ln>
-        </p:spPr>
-        <p:txBody>
-          <a:bodyPr spcFirstLastPara="1" wrap="square" lIns="91425" tIns="45700" rIns="91425" bIns="45700" anchor="ctr" anchorCtr="0">
-            <a:noAutofit/>
-          </a:bodyPr>
-          <a:lstStyle/>
-          <a:p>
-            <a:pPr marL="0" marR="0" lvl="0" indent="0" algn="ctr" rtl="0">
-              <a:spcBef>
-                <a:spcPts val="0"/>
-              </a:spcBef>
-              <a:spcAft>
-                <a:spcPts val="0"/>
-              </a:spcAft>
-              <a:buNone/>
-            </a:pPr>
-            <a:endParaRPr sz="1800" b="0" i="0" u="none" strike="noStrike" cap="none">
-              <a:solidFill>
-                <a:schemeClr val="dk1"/>
-              </a:solidFill>
-              <a:latin typeface="Calibri"/>
-              <a:ea typeface="Calibri"/>
-              <a:cs typeface="Calibri"/>
-              <a:sym typeface="Calibri"/>
-            </a:endParaRPr>
-          </a:p>
-        </p:txBody>
-      </p:sp>
-      <p:sp>
-        <p:nvSpPr>
-          <p:cNvPr id="210" name="Google Shape;210;p21"/>
-          <p:cNvSpPr txBox="1"/>
-          <p:nvPr/>
-        </p:nvSpPr>
-        <p:spPr>
-          <a:xfrm>
-            <a:off x="666750" y="4074318"/>
-            <a:ext cx="6229350" cy="542925"/>
-          </a:xfrm>
-          <a:prstGeom prst="rect">
-            <a:avLst/>
-          </a:prstGeom>
-          <a:noFill/>
-          <a:ln>
-            <a:noFill/>
-          </a:ln>
-        </p:spPr>
-        <p:txBody>
-          <a:bodyPr spcFirstLastPara="1" wrap="square" lIns="0" tIns="0" rIns="0" bIns="0" anchor="t" anchorCtr="0">
-            <a:spAutoFit/>
-          </a:bodyPr>
-          <a:lstStyle/>
-          <a:p>
-            <a:pPr marL="0" marR="0" lvl="0" indent="0" algn="l" rtl="0">
-              <a:lnSpc>
-                <a:spcPct val="149964"/>
-              </a:lnSpc>
-              <a:spcBef>
-                <a:spcPts val="0"/>
-              </a:spcBef>
-              <a:spcAft>
-                <a:spcPts val="0"/>
-              </a:spcAft>
-              <a:buNone/>
-            </a:pPr>
-            <a:r>
-              <a:rPr lang="en-US" sz="1425" b="0" i="0" u="none" strike="noStrike" cap="none" dirty="0">
-                <a:solidFill>
-                  <a:srgbClr val="0F172A"/>
-                </a:solidFill>
-                <a:latin typeface="Inter"/>
-                <a:ea typeface="Inter"/>
-                <a:cs typeface="Inter"/>
-                <a:sym typeface="Inter"/>
-              </a:rPr>
-              <a:t>Asynchronous UX:</a:t>
-            </a:r>
-            <a:r>
-              <a:rPr lang="en-US" sz="1425" b="0" i="0" u="none" strike="noStrike" cap="none" dirty="0">
-                <a:solidFill>
-                  <a:srgbClr val="334155"/>
-                </a:solidFill>
-                <a:latin typeface="Inter"/>
-                <a:ea typeface="Inter"/>
-                <a:cs typeface="Inter"/>
-                <a:sym typeface="Inter"/>
-              </a:rPr>
-              <a:t> Implemented visual loading states and error boundaries to handle data fetching latency gracefully.</a:t>
-            </a:r>
-            <a:endParaRPr dirty="0"/>
-          </a:p>
-        </p:txBody>
-      </p:sp>
     </p:spTree>
   </p:cSld>
   <p:clrMapOvr>

</xml_diff>